<commit_message>
Upgrade Psychology of Food deck with illustrated food art
Replace emoji with hand-built, appetizing SVG-rendered food illustrations
(burgers, pizza, salad, cake, memory foods) and clean line icons for the
perception/verdict flows. Enrich speaker notes with delivery cues on all
five slides. Adds food_art.js (illustration generator) and render_qa.py
(local visual-QA renderer).

Co-Authored-By: Claude Opus 4.8 <noreply@anthropic.com>
Claude-Session: https://claude.ai/code/session_018c6qB1U6jWUozGEQhQ7Rdm
</commit_message>
<xml_diff>
--- a/presentation/Psychology_of_Food.pptx
+++ b/presentation/Psychology_of_Food.pptx
@@ -508,8 +508,9 @@
               <a:rPr lang="en-US" dirty="0"/>
               <a:t>Hi everyone — I'm Nooha. Quick experiment before I say anything else.
 [Point to the screen.] Here are four foods. Don't overthink it — in the next five seconds, pick the ONE you'd want right now, and raise your hand for it when I call it out.
-[Pause 5 seconds. Then call each item and count hands.] Burger? Pizza? Salad? Dessert? … Interesting. Nobody agreed on nothing — and I promise none of you did any 'analysis.' You just knew.
-So here's my question for the next few minutes: WHY did you choose that? That's what the psychology of food is all about — the hidden reasons behind 'I just felt like it.' Let's dig in.</a:t>
+[Pause 5 seconds. Then call each item and count hands.] Burger? Pizza? Salad? Dessert? … Interesting — no two rooms ever agree, and I promise none of you did any 'analysis.' You just knew.
+So here's my question for the next few minutes: WHY did you choose that? That's what the psychology of food is all about — the hidden reasons behind 'I just felt like it.' Let's dig in.
+[Delivery tip: keep energy high, smile, and don't rush the 5-second countdown — the silence builds the hook.]</a:t>
             </a:r>
             <a:endParaRPr lang="en-US" dirty="0"/>
           </a:p>
@@ -598,8 +599,8 @@
             <a:r>
               <a:rPr lang="en-US" dirty="0"/>
               <a:t>Okay, first reason we choose what we choose: our eyes get there first.
-[Point to the two burgers.] Same burger — literally the same recipe. Quick show of hands: which one looks tastier, left or right? [Pause for hands — it'll be lopsided, play it up.] Right, of course. The one that's plated beautifully.
-Here's what's wild: before you've tasted anything, your brain has already decided. You SEE it, you EXPECT it to taste amazing, and that expectation actually shapes how good it tastes. Colour, lighting, plating — it's all quietly setting you up. So half the battle in food is won before the fork even moves.</a:t>
+[Point to the two burgers.] Same burger — literally the same recipe. Quick show of hands: which one looks tastier, left or right? [Pause for hands — it'll be lopsided, play it up.] Right, of course — the one that's plated beautifully.
+Here's what's wild: before you've tasted anything, your brain has already decided. You SEE it, you EXPECT it to taste amazing, and that expectation actually shapes how good it tastes. Colour, lighting, plating — all quietly setting you up. So half the battle in food is won before the fork even moves.</a:t>
             </a:r>
             <a:endParaRPr lang="en-US" dirty="0"/>
           </a:p>
@@ -688,8 +689,8 @@
             <a:r>
               <a:rPr lang="en-US" dirty="0"/>
               <a:t>Now let's talk about the menu — because the menu is quietly manipulating you, and honestly, it's brilliant.
-[Point to the menu.] Look at these two. A 'Classic Burger' for twelve dollars. Or the 'Chef's Signature Fire-Grilled Beef Burger with caramelised onions and house sauce' for fifteen. Quick — which one are you ordering? [Pause for a show of hands — most will pick the signature.]
-Here's the punchline: it might be the exact same burger. Same beef. All that changed was the words, the layout, and how it's presented. Descriptive language makes us expect more, so we happily pay more. So next time a menu makes your mouth water… just know the menu did that on purpose.</a:t>
+[Point to the menu.] Look at these two. A 'Classic Burger' for twelve dollars. Or the 'Chef's Signature Fire-Grilled Beef Burger with caramelised onions and house sauce' for fifteen. Quick — which one are you ordering? [Pause for a show of hands — most pick the signature.]
+Here's the punchline: it might be the exact same burger. Same beef. All that changed was the words, the layout, and how it's presented. Descriptive language makes us expect more, so we happily pay more. So next time a menu makes your mouth water… know that the menu did that on purpose.</a:t>
             </a:r>
             <a:endParaRPr lang="en-US" dirty="0"/>
           </a:p>
@@ -778,9 +779,9 @@
             <a:r>
               <a:rPr lang="en-US" dirty="0"/>
               <a:t>This next one is my favourite, because it's the most human. Food isn't just taste — it's memory.
-A certain smell and suddenly you're eight years old in your grandmother's kitchen. That's not an accident; food is wired straight to emotion and memory.
-[Turn to the audience — pick one friendly face.] Can I get one person — what's a food that instantly reminds you of home or childhood? [Let them answer. React warmly — 'oh, that's a good one.' Maybe share a one-line example of your own.]
-See — nobody says 'the one with the best nutrition label.' We remember who we ate it with. That feeling is doing a lot of the choosing for us.</a:t>
+A certain smell, and suddenly you're eight years old in your grandmother's kitchen. That's not an accident; food is wired straight to emotion and memory.
+[Turn to the audience — pick one friendly face.] Can I get one person — what's a food that instantly reminds you of home or childhood? [Let them answer. React warmly — 'oh, that's a good one.' Maybe share a quick one-line example of your own.]
+Notice nobody ever says 'the one with the best nutrition label.' We remember who we ate it with. That feeling is doing a lot of the choosing for us.</a:t>
             </a:r>
             <a:endParaRPr lang="en-US" dirty="0"/>
           </a:p>
@@ -1340,7 +1341,7 @@
               <a:buNone/>
             </a:pPr>
             <a:r>
-              <a:rPr lang="en-US" sz="5800" b="1" spc="100" kern="0" dirty="0">
+              <a:rPr lang="en-US" sz="5600" b="1" spc="100" kern="0" dirty="0">
                 <a:solidFill>
                   <a:srgbClr val="FDF6EC"/>
                 </a:solidFill>
@@ -1350,7 +1351,7 @@
               </a:rPr>
               <a:t>THE PSYCHOLOGY</a:t>
             </a:r>
-            <a:endParaRPr lang="en-US" sz="5800" dirty="0"/>
+            <a:endParaRPr lang="en-US" sz="5600" dirty="0"/>
           </a:p>
         </p:txBody>
       </p:sp>
@@ -1401,8 +1402,8 @@
         </p:nvSpPr>
         <p:spPr>
           <a:xfrm>
-            <a:off x="658368" y="3127248"/>
-            <a:ext cx="7315200" cy="548640"/>
+            <a:off x="658368" y="3154680"/>
+            <a:ext cx="7498080" cy="548640"/>
           </a:xfrm>
           <a:prstGeom prst="rect">
             <a:avLst/>
@@ -1440,7 +1441,7 @@
         </p:nvSpPr>
         <p:spPr>
           <a:xfrm>
-            <a:off x="658368" y="3977640"/>
+            <a:off x="658368" y="4069080"/>
             <a:ext cx="7498080" cy="731520"/>
           </a:xfrm>
           <a:prstGeom prst="rect">
@@ -1457,7 +1458,7 @@
               <a:buNone/>
             </a:pPr>
             <a:r>
-              <a:rPr lang="en-US" sz="3400" b="1" dirty="0">
+              <a:rPr lang="en-US" sz="3300" b="1" dirty="0">
                 <a:solidFill>
                   <a:srgbClr val="FDF6EC"/>
                 </a:solidFill>
@@ -1467,7 +1468,7 @@
               </a:rPr>
               <a:t>WHAT WOULD YOU CHOOSE?</a:t>
             </a:r>
-            <a:endParaRPr lang="en-US" sz="3400" dirty="0"/>
+            <a:endParaRPr lang="en-US" sz="3300" dirty="0"/>
           </a:p>
         </p:txBody>
       </p:sp>
@@ -1479,7 +1480,7 @@
         </p:nvSpPr>
         <p:spPr>
           <a:xfrm>
-            <a:off x="685800" y="4681728"/>
+            <a:off x="685800" y="4754880"/>
             <a:ext cx="7315200" cy="457200"/>
           </a:xfrm>
           <a:prstGeom prst="rect">
@@ -1557,37 +1558,60 @@
         </p:nvSpPr>
         <p:spPr>
           <a:xfrm>
-            <a:off x="8732520" y="822960"/>
-            <a:ext cx="1508760" cy="1508760"/>
+            <a:off x="8503920" y="868680"/>
+            <a:ext cx="1691640" cy="1828800"/>
           </a:xfrm>
           <a:prstGeom prst="roundRect">
             <a:avLst>
-              <a:gd name="adj" fmla="val 13333"/>
+              <a:gd name="adj" fmla="val 8649"/>
             </a:avLst>
           </a:prstGeom>
           <a:solidFill>
-            <a:srgbClr val="3A2318"/>
+            <a:srgbClr val="FBF3E9"/>
           </a:solidFill>
           <a:ln/>
           <a:effectLst>
             <a:outerShdw sx="100000" sy="100000" kx="0" ky="0" algn="bl" rotWithShape="0" blurRad="177800" dist="76200" dir="5400000">
               <a:srgbClr val="1C1109">
-                <a:alpha val="45000"/>
+                <a:alpha val="40000"/>
               </a:srgbClr>
             </a:outerShdw>
           </a:effectLst>
         </p:spPr>
       </p:sp>
-      <p:sp>
-        <p:nvSpPr>
-          <p:cNvPr id="12" name="Text 9"/>
-          <p:cNvSpPr/>
-          <p:nvPr/>
-        </p:nvSpPr>
-        <p:spPr>
-          <a:xfrm>
-            <a:off x="8732520" y="822960"/>
-            <a:ext cx="1508760" cy="1508760"/>
+      <p:pic>
+        <p:nvPicPr>
+          <p:cNvPr id="12" name="Image 0" descr="/home/user/Wristworkswebsite/presentation/art_burger.png">    </p:cNvPr>
+          <p:cNvPicPr>
+            <a:picLocks noChangeAspect="1"/>
+          </p:cNvPicPr>
+          <p:nvPr/>
+        </p:nvPicPr>
+        <p:blipFill>
+          <a:blip r:embed="rId2"/>
+          <a:srcRect l="0" r="0" t="0" b="0"/>
+          <a:stretch/>
+        </p:blipFill>
+        <p:spPr>
+          <a:xfrm>
+            <a:off x="8631936" y="996696"/>
+            <a:ext cx="1435608" cy="1280160"/>
+          </a:xfrm>
+          <a:prstGeom prst="rect">
+            <a:avLst/>
+          </a:prstGeom>
+        </p:spPr>
+      </p:pic>
+      <p:sp>
+        <p:nvSpPr>
+          <p:cNvPr id="13" name="Text 9"/>
+          <p:cNvSpPr/>
+          <p:nvPr/>
+        </p:nvSpPr>
+        <p:spPr>
+          <a:xfrm>
+            <a:off x="8503920" y="2313432"/>
+            <a:ext cx="1691640" cy="329184"/>
           </a:xfrm>
           <a:prstGeom prst="rect">
             <a:avLst/>
@@ -1603,45 +1627,9 @@
               <a:buNone/>
             </a:pPr>
             <a:r>
-              <a:rPr lang="en-US" sz="9600" dirty="0">
-                <a:solidFill>
-                  <a:srgbClr val="000000"/>
-                </a:solidFill>
-              </a:rPr>
-              <a:t>🍔</a:t>
-            </a:r>
-            <a:endParaRPr lang="en-US" sz="9600" dirty="0"/>
-          </a:p>
-        </p:txBody>
-      </p:sp>
-      <p:sp>
-        <p:nvSpPr>
-          <p:cNvPr id="13" name="Text 10"/>
-          <p:cNvSpPr/>
-          <p:nvPr/>
-        </p:nvSpPr>
-        <p:spPr>
-          <a:xfrm>
-            <a:off x="8732520" y="1764792"/>
-            <a:ext cx="1508760" cy="457200"/>
-          </a:xfrm>
-          <a:prstGeom prst="rect">
-            <a:avLst/>
-          </a:prstGeom>
-          <a:noFill/>
-          <a:ln/>
-        </p:spPr>
-        <p:txBody>
-          <a:bodyPr wrap="square" lIns="0" tIns="0" rIns="0" bIns="0" rtlCol="0" anchor="ctr"/>
-          <a:lstStyle/>
-          <a:p>
-            <a:pPr algn="ctr" indent="0" marL="0">
-              <a:buNone/>
-            </a:pPr>
-            <a:r>
               <a:rPr lang="en-US" sz="1300" b="1" spc="200" kern="0" dirty="0">
                 <a:solidFill>
-                  <a:srgbClr val="F0A868"/>
+                  <a:srgbClr val="2B1B14"/>
                 </a:solidFill>
                 <a:latin typeface="Montserrat" pitchFamily="34" charset="0"/>
                 <a:ea typeface="Montserrat" pitchFamily="34" charset="-122"/>
@@ -1655,43 +1643,66 @@
       </p:sp>
       <p:sp>
         <p:nvSpPr>
-          <p:cNvPr id="14" name="Shape 11"/>
-          <p:cNvSpPr/>
-          <p:nvPr/>
-        </p:nvSpPr>
-        <p:spPr>
-          <a:xfrm>
-            <a:off x="10378440" y="822960"/>
-            <a:ext cx="1508760" cy="1508760"/>
+          <p:cNvPr id="14" name="Shape 10"/>
+          <p:cNvSpPr/>
+          <p:nvPr/>
+        </p:nvSpPr>
+        <p:spPr>
+          <a:xfrm>
+            <a:off x="10396728" y="868680"/>
+            <a:ext cx="1691640" cy="1828800"/>
           </a:xfrm>
           <a:prstGeom prst="roundRect">
             <a:avLst>
-              <a:gd name="adj" fmla="val 13333"/>
+              <a:gd name="adj" fmla="val 8649"/>
             </a:avLst>
           </a:prstGeom>
           <a:solidFill>
-            <a:srgbClr val="3A2318"/>
+            <a:srgbClr val="FBF3E9"/>
           </a:solidFill>
           <a:ln/>
           <a:effectLst>
             <a:outerShdw sx="100000" sy="100000" kx="0" ky="0" algn="bl" rotWithShape="0" blurRad="177800" dist="76200" dir="5400000">
               <a:srgbClr val="1C1109">
-                <a:alpha val="45000"/>
+                <a:alpha val="40000"/>
               </a:srgbClr>
             </a:outerShdw>
           </a:effectLst>
         </p:spPr>
       </p:sp>
-      <p:sp>
-        <p:nvSpPr>
-          <p:cNvPr id="15" name="Text 12"/>
-          <p:cNvSpPr/>
-          <p:nvPr/>
-        </p:nvSpPr>
-        <p:spPr>
-          <a:xfrm>
-            <a:off x="10378440" y="822960"/>
-            <a:ext cx="1508760" cy="1508760"/>
+      <p:pic>
+        <p:nvPicPr>
+          <p:cNvPr id="15" name="Image 1" descr="/home/user/Wristworkswebsite/presentation/art_pizza.png">    </p:cNvPr>
+          <p:cNvPicPr>
+            <a:picLocks noChangeAspect="1"/>
+          </p:cNvPicPr>
+          <p:nvPr/>
+        </p:nvPicPr>
+        <p:blipFill>
+          <a:blip r:embed="rId3"/>
+          <a:srcRect l="0" r="0" t="0" b="0"/>
+          <a:stretch/>
+        </p:blipFill>
+        <p:spPr>
+          <a:xfrm>
+            <a:off x="10524744" y="996696"/>
+            <a:ext cx="1435608" cy="1280160"/>
+          </a:xfrm>
+          <a:prstGeom prst="rect">
+            <a:avLst/>
+          </a:prstGeom>
+        </p:spPr>
+      </p:pic>
+      <p:sp>
+        <p:nvSpPr>
+          <p:cNvPr id="16" name="Text 11"/>
+          <p:cNvSpPr/>
+          <p:nvPr/>
+        </p:nvSpPr>
+        <p:spPr>
+          <a:xfrm>
+            <a:off x="10396728" y="2313432"/>
+            <a:ext cx="1691640" cy="329184"/>
           </a:xfrm>
           <a:prstGeom prst="rect">
             <a:avLst/>
@@ -1707,45 +1718,9 @@
               <a:buNone/>
             </a:pPr>
             <a:r>
-              <a:rPr lang="en-US" sz="9600" dirty="0">
-                <a:solidFill>
-                  <a:srgbClr val="000000"/>
-                </a:solidFill>
-              </a:rPr>
-              <a:t>🍕</a:t>
-            </a:r>
-            <a:endParaRPr lang="en-US" sz="9600" dirty="0"/>
-          </a:p>
-        </p:txBody>
-      </p:sp>
-      <p:sp>
-        <p:nvSpPr>
-          <p:cNvPr id="16" name="Text 13"/>
-          <p:cNvSpPr/>
-          <p:nvPr/>
-        </p:nvSpPr>
-        <p:spPr>
-          <a:xfrm>
-            <a:off x="10378440" y="1764792"/>
-            <a:ext cx="1508760" cy="457200"/>
-          </a:xfrm>
-          <a:prstGeom prst="rect">
-            <a:avLst/>
-          </a:prstGeom>
-          <a:noFill/>
-          <a:ln/>
-        </p:spPr>
-        <p:txBody>
-          <a:bodyPr wrap="square" lIns="0" tIns="0" rIns="0" bIns="0" rtlCol="0" anchor="ctr"/>
-          <a:lstStyle/>
-          <a:p>
-            <a:pPr algn="ctr" indent="0" marL="0">
-              <a:buNone/>
-            </a:pPr>
-            <a:r>
               <a:rPr lang="en-US" sz="1300" b="1" spc="200" kern="0" dirty="0">
                 <a:solidFill>
-                  <a:srgbClr val="F0A868"/>
+                  <a:srgbClr val="2B1B14"/>
                 </a:solidFill>
                 <a:latin typeface="Montserrat" pitchFamily="34" charset="0"/>
                 <a:ea typeface="Montserrat" pitchFamily="34" charset="-122"/>
@@ -1759,43 +1734,66 @@
       </p:sp>
       <p:sp>
         <p:nvSpPr>
-          <p:cNvPr id="17" name="Shape 14"/>
-          <p:cNvSpPr/>
-          <p:nvPr/>
-        </p:nvSpPr>
-        <p:spPr>
-          <a:xfrm>
-            <a:off x="8732520" y="2514600"/>
-            <a:ext cx="1508760" cy="1508760"/>
+          <p:cNvPr id="17" name="Shape 12"/>
+          <p:cNvSpPr/>
+          <p:nvPr/>
+        </p:nvSpPr>
+        <p:spPr>
+          <a:xfrm>
+            <a:off x="8503920" y="2898648"/>
+            <a:ext cx="1691640" cy="1828800"/>
           </a:xfrm>
           <a:prstGeom prst="roundRect">
             <a:avLst>
-              <a:gd name="adj" fmla="val 13333"/>
+              <a:gd name="adj" fmla="val 8649"/>
             </a:avLst>
           </a:prstGeom>
           <a:solidFill>
-            <a:srgbClr val="3A2318"/>
+            <a:srgbClr val="FBF3E9"/>
           </a:solidFill>
           <a:ln/>
           <a:effectLst>
             <a:outerShdw sx="100000" sy="100000" kx="0" ky="0" algn="bl" rotWithShape="0" blurRad="177800" dist="76200" dir="5400000">
               <a:srgbClr val="1C1109">
-                <a:alpha val="45000"/>
+                <a:alpha val="40000"/>
               </a:srgbClr>
             </a:outerShdw>
           </a:effectLst>
         </p:spPr>
       </p:sp>
-      <p:sp>
-        <p:nvSpPr>
-          <p:cNvPr id="18" name="Text 15"/>
-          <p:cNvSpPr/>
-          <p:nvPr/>
-        </p:nvSpPr>
-        <p:spPr>
-          <a:xfrm>
-            <a:off x="8732520" y="2514600"/>
-            <a:ext cx="1508760" cy="1508760"/>
+      <p:pic>
+        <p:nvPicPr>
+          <p:cNvPr id="18" name="Image 2" descr="/home/user/Wristworkswebsite/presentation/art_salad.png">    </p:cNvPr>
+          <p:cNvPicPr>
+            <a:picLocks noChangeAspect="1"/>
+          </p:cNvPicPr>
+          <p:nvPr/>
+        </p:nvPicPr>
+        <p:blipFill>
+          <a:blip r:embed="rId4"/>
+          <a:srcRect l="0" r="0" t="0" b="0"/>
+          <a:stretch/>
+        </p:blipFill>
+        <p:spPr>
+          <a:xfrm>
+            <a:off x="8631936" y="3026664"/>
+            <a:ext cx="1435608" cy="1280160"/>
+          </a:xfrm>
+          <a:prstGeom prst="rect">
+            <a:avLst/>
+          </a:prstGeom>
+        </p:spPr>
+      </p:pic>
+      <p:sp>
+        <p:nvSpPr>
+          <p:cNvPr id="19" name="Text 13"/>
+          <p:cNvSpPr/>
+          <p:nvPr/>
+        </p:nvSpPr>
+        <p:spPr>
+          <a:xfrm>
+            <a:off x="8503920" y="4343400"/>
+            <a:ext cx="1691640" cy="329184"/>
           </a:xfrm>
           <a:prstGeom prst="rect">
             <a:avLst/>
@@ -1811,45 +1809,9 @@
               <a:buNone/>
             </a:pPr>
             <a:r>
-              <a:rPr lang="en-US" sz="9600" dirty="0">
-                <a:solidFill>
-                  <a:srgbClr val="000000"/>
-                </a:solidFill>
-              </a:rPr>
-              <a:t>🥗</a:t>
-            </a:r>
-            <a:endParaRPr lang="en-US" sz="9600" dirty="0"/>
-          </a:p>
-        </p:txBody>
-      </p:sp>
-      <p:sp>
-        <p:nvSpPr>
-          <p:cNvPr id="19" name="Text 16"/>
-          <p:cNvSpPr/>
-          <p:nvPr/>
-        </p:nvSpPr>
-        <p:spPr>
-          <a:xfrm>
-            <a:off x="8732520" y="3456432"/>
-            <a:ext cx="1508760" cy="457200"/>
-          </a:xfrm>
-          <a:prstGeom prst="rect">
-            <a:avLst/>
-          </a:prstGeom>
-          <a:noFill/>
-          <a:ln/>
-        </p:spPr>
-        <p:txBody>
-          <a:bodyPr wrap="square" lIns="0" tIns="0" rIns="0" bIns="0" rtlCol="0" anchor="ctr"/>
-          <a:lstStyle/>
-          <a:p>
-            <a:pPr algn="ctr" indent="0" marL="0">
-              <a:buNone/>
-            </a:pPr>
-            <a:r>
               <a:rPr lang="en-US" sz="1300" b="1" spc="200" kern="0" dirty="0">
                 <a:solidFill>
-                  <a:srgbClr val="F0A868"/>
+                  <a:srgbClr val="2B1B14"/>
                 </a:solidFill>
                 <a:latin typeface="Montserrat" pitchFamily="34" charset="0"/>
                 <a:ea typeface="Montserrat" pitchFamily="34" charset="-122"/>
@@ -1863,43 +1825,66 @@
       </p:sp>
       <p:sp>
         <p:nvSpPr>
-          <p:cNvPr id="20" name="Shape 17"/>
-          <p:cNvSpPr/>
-          <p:nvPr/>
-        </p:nvSpPr>
-        <p:spPr>
-          <a:xfrm>
-            <a:off x="10378440" y="2514600"/>
-            <a:ext cx="1508760" cy="1508760"/>
+          <p:cNvPr id="20" name="Shape 14"/>
+          <p:cNvSpPr/>
+          <p:nvPr/>
+        </p:nvSpPr>
+        <p:spPr>
+          <a:xfrm>
+            <a:off x="10396728" y="2898648"/>
+            <a:ext cx="1691640" cy="1828800"/>
           </a:xfrm>
           <a:prstGeom prst="roundRect">
             <a:avLst>
-              <a:gd name="adj" fmla="val 13333"/>
+              <a:gd name="adj" fmla="val 8649"/>
             </a:avLst>
           </a:prstGeom>
           <a:solidFill>
-            <a:srgbClr val="3A2318"/>
+            <a:srgbClr val="FBF3E9"/>
           </a:solidFill>
           <a:ln/>
           <a:effectLst>
             <a:outerShdw sx="100000" sy="100000" kx="0" ky="0" algn="bl" rotWithShape="0" blurRad="177800" dist="76200" dir="5400000">
               <a:srgbClr val="1C1109">
-                <a:alpha val="45000"/>
+                <a:alpha val="40000"/>
               </a:srgbClr>
             </a:outerShdw>
           </a:effectLst>
         </p:spPr>
       </p:sp>
-      <p:sp>
-        <p:nvSpPr>
-          <p:cNvPr id="21" name="Text 18"/>
-          <p:cNvSpPr/>
-          <p:nvPr/>
-        </p:nvSpPr>
-        <p:spPr>
-          <a:xfrm>
-            <a:off x="10378440" y="2514600"/>
-            <a:ext cx="1508760" cy="1508760"/>
+      <p:pic>
+        <p:nvPicPr>
+          <p:cNvPr id="21" name="Image 3" descr="/home/user/Wristworkswebsite/presentation/art_cake.png">    </p:cNvPr>
+          <p:cNvPicPr>
+            <a:picLocks noChangeAspect="1"/>
+          </p:cNvPicPr>
+          <p:nvPr/>
+        </p:nvPicPr>
+        <p:blipFill>
+          <a:blip r:embed="rId5"/>
+          <a:srcRect l="0" r="0" t="0" b="0"/>
+          <a:stretch/>
+        </p:blipFill>
+        <p:spPr>
+          <a:xfrm>
+            <a:off x="10524744" y="3026664"/>
+            <a:ext cx="1435608" cy="1280160"/>
+          </a:xfrm>
+          <a:prstGeom prst="rect">
+            <a:avLst/>
+          </a:prstGeom>
+        </p:spPr>
+      </p:pic>
+      <p:sp>
+        <p:nvSpPr>
+          <p:cNvPr id="22" name="Text 15"/>
+          <p:cNvSpPr/>
+          <p:nvPr/>
+        </p:nvSpPr>
+        <p:spPr>
+          <a:xfrm>
+            <a:off x="10396728" y="4343400"/>
+            <a:ext cx="1691640" cy="329184"/>
           </a:xfrm>
           <a:prstGeom prst="rect">
             <a:avLst/>
@@ -1915,45 +1900,9 @@
               <a:buNone/>
             </a:pPr>
             <a:r>
-              <a:rPr lang="en-US" sz="9600" dirty="0">
-                <a:solidFill>
-                  <a:srgbClr val="000000"/>
-                </a:solidFill>
-              </a:rPr>
-              <a:t>🍰</a:t>
-            </a:r>
-            <a:endParaRPr lang="en-US" sz="9600" dirty="0"/>
-          </a:p>
-        </p:txBody>
-      </p:sp>
-      <p:sp>
-        <p:nvSpPr>
-          <p:cNvPr id="22" name="Text 19"/>
-          <p:cNvSpPr/>
-          <p:nvPr/>
-        </p:nvSpPr>
-        <p:spPr>
-          <a:xfrm>
-            <a:off x="10378440" y="3456432"/>
-            <a:ext cx="1508760" cy="457200"/>
-          </a:xfrm>
-          <a:prstGeom prst="rect">
-            <a:avLst/>
-          </a:prstGeom>
-          <a:noFill/>
-          <a:ln/>
-        </p:spPr>
-        <p:txBody>
-          <a:bodyPr wrap="square" lIns="0" tIns="0" rIns="0" bIns="0" rtlCol="0" anchor="ctr"/>
-          <a:lstStyle/>
-          <a:p>
-            <a:pPr algn="ctr" indent="0" marL="0">
-              <a:buNone/>
-            </a:pPr>
-            <a:r>
               <a:rPr lang="en-US" sz="1300" b="1" spc="200" kern="0" dirty="0">
                 <a:solidFill>
-                  <a:srgbClr val="F0A868"/>
+                  <a:srgbClr val="2B1B14"/>
                 </a:solidFill>
                 <a:latin typeface="Montserrat" pitchFamily="34" charset="0"/>
                 <a:ea typeface="Montserrat" pitchFamily="34" charset="-122"/>
@@ -1967,14 +1916,14 @@
       </p:sp>
       <p:sp>
         <p:nvSpPr>
-          <p:cNvPr id="23" name="Text 20"/>
-          <p:cNvSpPr/>
-          <p:nvPr/>
-        </p:nvSpPr>
-        <p:spPr>
-          <a:xfrm>
-            <a:off x="8595360" y="4343400"/>
-            <a:ext cx="3200400" cy="457200"/>
+          <p:cNvPr id="23" name="Text 16"/>
+          <p:cNvSpPr/>
+          <p:nvPr/>
+        </p:nvSpPr>
+        <p:spPr>
+          <a:xfrm>
+            <a:off x="8503920" y="4837176"/>
+            <a:ext cx="3584448" cy="457200"/>
           </a:xfrm>
           <a:prstGeom prst="rect">
             <a:avLst/>
@@ -2045,7 +1994,7 @@
       </p:grpSpPr>
       <p:sp>
         <p:nvSpPr>
-          <p:cNvPr id="2" name="Shape 0"/>
+          <p:cNvPr id="3" name="Shape 0"/>
           <p:cNvSpPr/>
           <p:nvPr/>
         </p:nvSpPr>
@@ -2067,7 +2016,7 @@
       </p:sp>
       <p:sp>
         <p:nvSpPr>
-          <p:cNvPr id="3" name="Text 1"/>
+          <p:cNvPr id="4" name="Text 1"/>
           <p:cNvSpPr/>
           <p:nvPr/>
         </p:nvSpPr>
@@ -2106,7 +2055,7 @@
       </p:sp>
       <p:sp>
         <p:nvSpPr>
-          <p:cNvPr id="4" name="Text 2"/>
+          <p:cNvPr id="5" name="Text 2"/>
           <p:cNvSpPr/>
           <p:nvPr/>
         </p:nvSpPr>
@@ -2159,14 +2108,14 @@
       </p:sp>
       <p:sp>
         <p:nvSpPr>
-          <p:cNvPr id="5" name="Text 3"/>
+          <p:cNvPr id="6" name="Text 3"/>
           <p:cNvSpPr/>
           <p:nvPr/>
         </p:nvSpPr>
         <p:spPr>
           <a:xfrm>
             <a:off x="658368" y="1874520"/>
-            <a:ext cx="10972800" cy="548640"/>
+            <a:ext cx="8229600" cy="548640"/>
           </a:xfrm>
           <a:prstGeom prst="rect">
             <a:avLst/>
@@ -2198,81 +2147,179 @@
       </p:sp>
       <p:sp>
         <p:nvSpPr>
-          <p:cNvPr id="6" name="Shape 4"/>
-          <p:cNvSpPr/>
-          <p:nvPr/>
-        </p:nvSpPr>
-        <p:spPr>
-          <a:xfrm>
-            <a:off x="685800" y="2606040"/>
-            <a:ext cx="4206240" cy="2331720"/>
+          <p:cNvPr id="7" name="Shape 4"/>
+          <p:cNvSpPr/>
+          <p:nvPr/>
+        </p:nvSpPr>
+        <p:spPr>
+          <a:xfrm>
+            <a:off x="685800" y="2560320"/>
+            <a:ext cx="3977640" cy="2468880"/>
           </a:xfrm>
           <a:prstGeom prst="roundRect">
             <a:avLst>
-              <a:gd name="adj" fmla="val 7843"/>
+              <a:gd name="adj" fmla="val 6667"/>
             </a:avLst>
           </a:prstGeom>
           <a:solidFill>
-            <a:srgbClr val="EAD9C4"/>
+            <a:srgbClr val="E4DACE"/>
           </a:solidFill>
           <a:ln/>
           <a:effectLst>
-            <a:outerShdw sx="100000" sy="100000" kx="0" ky="0" algn="bl" rotWithShape="0" blurRad="152400" dist="63500" dir="5400000">
+            <a:outerShdw sx="100000" sy="100000" kx="0" ky="0" algn="bl" rotWithShape="0" blurRad="127000" dist="50800" dir="5400000">
               <a:srgbClr val="B79A7E">
+                <a:alpha val="35000"/>
+              </a:srgbClr>
+            </a:outerShdw>
+          </a:effectLst>
+        </p:spPr>
+      </p:sp>
+      <p:pic>
+        <p:nvPicPr>
+          <p:cNvPr id="8" name="Image 0" descr="/home/user/Wristworkswebsite/presentation/art_burger_plain.png">    </p:cNvPr>
+          <p:cNvPicPr>
+            <a:picLocks noChangeAspect="1"/>
+          </p:cNvPicPr>
+          <p:nvPr/>
+        </p:nvPicPr>
+        <p:blipFill>
+          <a:blip r:embed="rId2"/>
+          <a:srcRect l="0" r="0" t="0" b="0"/>
+          <a:stretch/>
+        </p:blipFill>
+        <p:spPr>
+          <a:xfrm>
+            <a:off x="914400" y="2743200"/>
+            <a:ext cx="3520440" cy="1645920"/>
+          </a:xfrm>
+          <a:prstGeom prst="rect">
+            <a:avLst/>
+          </a:prstGeom>
+        </p:spPr>
+      </p:pic>
+      <p:sp>
+        <p:nvSpPr>
+          <p:cNvPr id="9" name="Shape 5"/>
+          <p:cNvSpPr/>
+          <p:nvPr/>
+        </p:nvSpPr>
+        <p:spPr>
+          <a:xfrm>
+            <a:off x="2194560" y="4480560"/>
+            <a:ext cx="960120" cy="384048"/>
+          </a:xfrm>
+          <a:prstGeom prst="roundRect">
+            <a:avLst>
+              <a:gd name="adj" fmla="val 50000"/>
+            </a:avLst>
+          </a:prstGeom>
+          <a:solidFill>
+            <a:srgbClr val="9C8570"/>
+          </a:solidFill>
+          <a:ln/>
+        </p:spPr>
+      </p:sp>
+      <p:sp>
+        <p:nvSpPr>
+          <p:cNvPr id="10" name="Text 6"/>
+          <p:cNvSpPr/>
+          <p:nvPr/>
+        </p:nvSpPr>
+        <p:spPr>
+          <a:xfrm>
+            <a:off x="2194560" y="4480560"/>
+            <a:ext cx="960120" cy="384048"/>
+          </a:xfrm>
+          <a:prstGeom prst="rect">
+            <a:avLst/>
+          </a:prstGeom>
+          <a:noFill/>
+          <a:ln/>
+        </p:spPr>
+        <p:txBody>
+          <a:bodyPr wrap="square" lIns="0" tIns="0" rIns="0" bIns="0" rtlCol="0" anchor="ctr"/>
+          <a:lstStyle/>
+          <a:p>
+            <a:pPr algn="ctr" indent="0" marL="0">
+              <a:buNone/>
+            </a:pPr>
+            <a:r>
+              <a:rPr lang="en-US" sz="1300" b="1" spc="200" kern="0" dirty="0">
+                <a:solidFill>
+                  <a:srgbClr val="FDF6EC"/>
+                </a:solidFill>
+                <a:latin typeface="Montserrat" pitchFamily="34" charset="0"/>
+                <a:ea typeface="Montserrat" pitchFamily="34" charset="-122"/>
+                <a:cs typeface="Montserrat" pitchFamily="34" charset="-120"/>
+              </a:rPr>
+              <a:t>PLAIN</a:t>
+            </a:r>
+            <a:endParaRPr lang="en-US" sz="1300" dirty="0"/>
+          </a:p>
+        </p:txBody>
+      </p:sp>
+      <p:sp>
+        <p:nvSpPr>
+          <p:cNvPr id="11" name="Shape 7"/>
+          <p:cNvSpPr/>
+          <p:nvPr/>
+        </p:nvSpPr>
+        <p:spPr>
+          <a:xfrm>
+            <a:off x="4983480" y="2560320"/>
+            <a:ext cx="3977640" cy="2468880"/>
+          </a:xfrm>
+          <a:prstGeom prst="roundRect">
+            <a:avLst>
+              <a:gd name="adj" fmla="val 6667"/>
+            </a:avLst>
+          </a:prstGeom>
+          <a:solidFill>
+            <a:srgbClr val="FBF1E4"/>
+          </a:solidFill>
+          <a:ln/>
+          <a:effectLst>
+            <a:outerShdw sx="100000" sy="100000" kx="0" ky="0" algn="bl" rotWithShape="0" blurRad="228600" dist="88900" dir="5400000">
+              <a:srgbClr val="7a3b1d">
                 <a:alpha val="40000"/>
               </a:srgbClr>
             </a:outerShdw>
           </a:effectLst>
         </p:spPr>
       </p:sp>
-      <p:sp>
-        <p:nvSpPr>
-          <p:cNvPr id="7" name="Text 5"/>
-          <p:cNvSpPr/>
-          <p:nvPr/>
-        </p:nvSpPr>
-        <p:spPr>
-          <a:xfrm>
-            <a:off x="685800" y="2560320"/>
-            <a:ext cx="4206240" cy="1874520"/>
-          </a:xfrm>
-          <a:prstGeom prst="rect">
-            <a:avLst/>
-          </a:prstGeom>
-          <a:noFill/>
-          <a:ln/>
-        </p:spPr>
-        <p:txBody>
-          <a:bodyPr wrap="square" lIns="0" tIns="0" rIns="0" bIns="0" rtlCol="0" anchor="ctr"/>
-          <a:lstStyle/>
-          <a:p>
-            <a:pPr algn="ctr" indent="0" marL="0">
-              <a:buNone/>
-            </a:pPr>
-            <a:r>
-              <a:rPr lang="en-US" sz="12000" dirty="0">
-                <a:solidFill>
-                  <a:srgbClr val="000000">
-                    <a:alpha val="78000"/>
-                  </a:srgbClr>
-                </a:solidFill>
-              </a:rPr>
-              <a:t>🍔</a:t>
-            </a:r>
-            <a:endParaRPr lang="en-US" sz="12000" dirty="0"/>
-          </a:p>
-        </p:txBody>
-      </p:sp>
-      <p:sp>
-        <p:nvSpPr>
-          <p:cNvPr id="8" name="Shape 6"/>
-          <p:cNvSpPr/>
-          <p:nvPr/>
-        </p:nvSpPr>
-        <p:spPr>
-          <a:xfrm>
-            <a:off x="2331720" y="4370832"/>
-            <a:ext cx="960120" cy="384048"/>
+      <p:pic>
+        <p:nvPicPr>
+          <p:cNvPr id="12" name="Image 1" descr="/home/user/Wristworkswebsite/presentation/art_burger.png">    </p:cNvPr>
+          <p:cNvPicPr>
+            <a:picLocks noChangeAspect="1"/>
+          </p:cNvPicPr>
+          <p:nvPr/>
+        </p:nvPicPr>
+        <p:blipFill>
+          <a:blip r:embed="rId3"/>
+          <a:srcRect l="0" r="0" t="0" b="0"/>
+          <a:stretch/>
+        </p:blipFill>
+        <p:spPr>
+          <a:xfrm>
+            <a:off x="5166360" y="2743200"/>
+            <a:ext cx="3611880" cy="1645920"/>
+          </a:xfrm>
+          <a:prstGeom prst="rect">
+            <a:avLst/>
+          </a:prstGeom>
+        </p:spPr>
+      </p:pic>
+      <p:sp>
+        <p:nvSpPr>
+          <p:cNvPr id="13" name="Shape 8"/>
+          <p:cNvSpPr/>
+          <p:nvPr/>
+        </p:nvSpPr>
+        <p:spPr>
+          <a:xfrm>
+            <a:off x="5875020" y="4480560"/>
+            <a:ext cx="2194560" cy="384048"/>
           </a:xfrm>
           <a:prstGeom prst="roundRect">
             <a:avLst>
@@ -2280,21 +2327,21 @@
             </a:avLst>
           </a:prstGeom>
           <a:solidFill>
-            <a:srgbClr val="9C8570"/>
+            <a:srgbClr val="E8722C"/>
           </a:solidFill>
           <a:ln/>
         </p:spPr>
       </p:sp>
       <p:sp>
         <p:nvSpPr>
-          <p:cNvPr id="9" name="Text 7"/>
-          <p:cNvSpPr/>
-          <p:nvPr/>
-        </p:nvSpPr>
-        <p:spPr>
-          <a:xfrm>
-            <a:off x="2331720" y="4370832"/>
-            <a:ext cx="960120" cy="384048"/>
+          <p:cNvPr id="14" name="Text 9"/>
+          <p:cNvSpPr/>
+          <p:nvPr/>
+        </p:nvSpPr>
+        <p:spPr>
+          <a:xfrm>
+            <a:off x="5875020" y="4480560"/>
+            <a:ext cx="2194560" cy="384048"/>
           </a:xfrm>
           <a:prstGeom prst="rect">
             <a:avLst/>
@@ -2312,13 +2359,13 @@
             <a:r>
               <a:rPr lang="en-US" sz="1300" b="1" spc="200" kern="0" dirty="0">
                 <a:solidFill>
-                  <a:srgbClr val="FDF6EC"/>
-                </a:solidFill>
-                <a:latin typeface="Montserrat" pitchFamily="34" charset="0"/>
-                <a:ea typeface="Montserrat" pitchFamily="34" charset="-122"/>
-                <a:cs typeface="Montserrat" pitchFamily="34" charset="-120"/>
-              </a:rPr>
-              <a:t>PLAIN</a:t>
+                  <a:srgbClr val="1C1109"/>
+                </a:solidFill>
+                <a:latin typeface="Montserrat" pitchFamily="34" charset="0"/>
+                <a:ea typeface="Montserrat" pitchFamily="34" charset="-122"/>
+                <a:cs typeface="Montserrat" pitchFamily="34" charset="-120"/>
+              </a:rPr>
+              <a:t>PLATED WITH LOVE</a:t>
             </a:r>
             <a:endParaRPr lang="en-US" sz="1300" dirty="0"/>
           </a:p>
@@ -2326,79 +2373,14 @@
       </p:sp>
       <p:sp>
         <p:nvSpPr>
-          <p:cNvPr id="10" name="Shape 8"/>
-          <p:cNvSpPr/>
-          <p:nvPr/>
-        </p:nvSpPr>
-        <p:spPr>
-          <a:xfrm>
-            <a:off x="5120640" y="2606040"/>
-            <a:ext cx="4206240" cy="2331720"/>
-          </a:xfrm>
-          <a:prstGeom prst="roundRect">
-            <a:avLst>
-              <a:gd name="adj" fmla="val 7843"/>
-            </a:avLst>
-          </a:prstGeom>
-          <a:solidFill>
-            <a:srgbClr val="3A2318"/>
-          </a:solidFill>
-          <a:ln/>
-          <a:effectLst>
-            <a:outerShdw sx="100000" sy="100000" kx="0" ky="0" algn="bl" rotWithShape="0" blurRad="203200" dist="76200" dir="5400000">
-              <a:srgbClr val="7a3b1d">
-                <a:alpha val="55000"/>
-              </a:srgbClr>
-            </a:outerShdw>
-          </a:effectLst>
-        </p:spPr>
-      </p:sp>
-      <p:sp>
-        <p:nvSpPr>
-          <p:cNvPr id="11" name="Text 9"/>
-          <p:cNvSpPr/>
-          <p:nvPr/>
-        </p:nvSpPr>
-        <p:spPr>
-          <a:xfrm>
-            <a:off x="5120640" y="2560320"/>
-            <a:ext cx="4206240" cy="1874520"/>
-          </a:xfrm>
-          <a:prstGeom prst="rect">
-            <a:avLst/>
-          </a:prstGeom>
-          <a:noFill/>
-          <a:ln/>
-        </p:spPr>
-        <p:txBody>
-          <a:bodyPr wrap="square" lIns="0" tIns="0" rIns="0" bIns="0" rtlCol="0" anchor="ctr"/>
-          <a:lstStyle/>
-          <a:p>
-            <a:pPr algn="ctr" indent="0" marL="0">
-              <a:buNone/>
-            </a:pPr>
-            <a:r>
-              <a:rPr lang="en-US" sz="13200" dirty="0">
-                <a:solidFill>
-                  <a:srgbClr val="000000"/>
-                </a:solidFill>
-              </a:rPr>
-              <a:t>🍔</a:t>
-            </a:r>
-            <a:endParaRPr lang="en-US" sz="13200" dirty="0"/>
-          </a:p>
-        </p:txBody>
-      </p:sp>
-      <p:sp>
-        <p:nvSpPr>
-          <p:cNvPr id="12" name="Shape 10"/>
-          <p:cNvSpPr/>
-          <p:nvPr/>
-        </p:nvSpPr>
-        <p:spPr>
-          <a:xfrm>
-            <a:off x="6126480" y="4370832"/>
-            <a:ext cx="2194560" cy="384048"/>
+          <p:cNvPr id="15" name="Shape 10"/>
+          <p:cNvSpPr/>
+          <p:nvPr/>
+        </p:nvSpPr>
+        <p:spPr>
+          <a:xfrm>
+            <a:off x="8046720" y="2697480"/>
+            <a:ext cx="841248" cy="438912"/>
           </a:xfrm>
           <a:prstGeom prst="roundRect">
             <a:avLst>
@@ -2406,67 +2388,6 @@
             </a:avLst>
           </a:prstGeom>
           <a:solidFill>
-            <a:srgbClr val="E8722C"/>
-          </a:solidFill>
-          <a:ln/>
-        </p:spPr>
-      </p:sp>
-      <p:sp>
-        <p:nvSpPr>
-          <p:cNvPr id="13" name="Text 11"/>
-          <p:cNvSpPr/>
-          <p:nvPr/>
-        </p:nvSpPr>
-        <p:spPr>
-          <a:xfrm>
-            <a:off x="6126480" y="4370832"/>
-            <a:ext cx="2194560" cy="384048"/>
-          </a:xfrm>
-          <a:prstGeom prst="rect">
-            <a:avLst/>
-          </a:prstGeom>
-          <a:noFill/>
-          <a:ln/>
-        </p:spPr>
-        <p:txBody>
-          <a:bodyPr wrap="square" lIns="0" tIns="0" rIns="0" bIns="0" rtlCol="0" anchor="ctr"/>
-          <a:lstStyle/>
-          <a:p>
-            <a:pPr algn="ctr" indent="0" marL="0">
-              <a:buNone/>
-            </a:pPr>
-            <a:r>
-              <a:rPr lang="en-US" sz="1300" b="1" spc="200" kern="0" dirty="0">
-                <a:solidFill>
-                  <a:srgbClr val="1C1109"/>
-                </a:solidFill>
-                <a:latin typeface="Montserrat" pitchFamily="34" charset="0"/>
-                <a:ea typeface="Montserrat" pitchFamily="34" charset="-122"/>
-                <a:cs typeface="Montserrat" pitchFamily="34" charset="-120"/>
-              </a:rPr>
-              <a:t>PLATED WITH LOVE</a:t>
-            </a:r>
-            <a:endParaRPr lang="en-US" sz="1300" dirty="0"/>
-          </a:p>
-        </p:txBody>
-      </p:sp>
-      <p:sp>
-        <p:nvSpPr>
-          <p:cNvPr id="14" name="Shape 12"/>
-          <p:cNvSpPr/>
-          <p:nvPr/>
-        </p:nvSpPr>
-        <p:spPr>
-          <a:xfrm>
-            <a:off x="8366760" y="2770632"/>
-            <a:ext cx="868680" cy="457200"/>
-          </a:xfrm>
-          <a:prstGeom prst="roundRect">
-            <a:avLst>
-              <a:gd name="adj" fmla="val 50000"/>
-            </a:avLst>
-          </a:prstGeom>
-          <a:solidFill>
             <a:srgbClr val="D9433C"/>
           </a:solidFill>
           <a:ln/>
@@ -2474,14 +2395,14 @@
       </p:sp>
       <p:sp>
         <p:nvSpPr>
-          <p:cNvPr id="15" name="Text 13"/>
-          <p:cNvSpPr/>
-          <p:nvPr/>
-        </p:nvSpPr>
-        <p:spPr>
-          <a:xfrm>
-            <a:off x="8366760" y="2770632"/>
-            <a:ext cx="868680" cy="457200"/>
+          <p:cNvPr id="16" name="Text 11"/>
+          <p:cNvSpPr/>
+          <p:nvPr/>
+        </p:nvSpPr>
+        <p:spPr>
+          <a:xfrm>
+            <a:off x="8046720" y="2697480"/>
+            <a:ext cx="841248" cy="438912"/>
           </a:xfrm>
           <a:prstGeom prst="rect">
             <a:avLst/>
@@ -2513,14 +2434,14 @@
       </p:sp>
       <p:sp>
         <p:nvSpPr>
-          <p:cNvPr id="16" name="Shape 14"/>
-          <p:cNvSpPr/>
-          <p:nvPr/>
-        </p:nvSpPr>
-        <p:spPr>
-          <a:xfrm>
-            <a:off x="9646920" y="960120"/>
-            <a:ext cx="1828800" cy="1051560"/>
+          <p:cNvPr id="17" name="Shape 12"/>
+          <p:cNvSpPr/>
+          <p:nvPr/>
+        </p:nvSpPr>
+        <p:spPr>
+          <a:xfrm>
+            <a:off x="9601200" y="1234440"/>
+            <a:ext cx="1965960" cy="1051560"/>
           </a:xfrm>
           <a:prstGeom prst="roundRect">
             <a:avLst>
@@ -2540,16 +2461,78 @@
           </a:effectLst>
         </p:spPr>
       </p:sp>
-      <p:sp>
-        <p:nvSpPr>
-          <p:cNvPr id="17" name="Text 15"/>
-          <p:cNvSpPr/>
-          <p:nvPr/>
-        </p:nvSpPr>
-        <p:spPr>
-          <a:xfrm>
-            <a:off x="9646920" y="1014984"/>
-            <a:ext cx="822960" cy="941832"/>
+      <p:pic>
+        <p:nvPicPr>
+          <p:cNvPr id="18" name="Image 2" descr="/home/user/Wristworkswebsite/presentation/icon_eye.png">    </p:cNvPr>
+          <p:cNvPicPr>
+            <a:picLocks noChangeAspect="1"/>
+          </p:cNvPicPr>
+          <p:nvPr/>
+        </p:nvPicPr>
+        <p:blipFill>
+          <a:blip r:embed="rId4"/>
+          <a:srcRect l="0" r="0" t="0" b="0"/>
+          <a:stretch/>
+        </p:blipFill>
+        <p:spPr>
+          <a:xfrm>
+            <a:off x="9747504" y="1417320"/>
+            <a:ext cx="685800" cy="685800"/>
+          </a:xfrm>
+          <a:prstGeom prst="rect">
+            <a:avLst/>
+          </a:prstGeom>
+        </p:spPr>
+      </p:pic>
+      <p:sp>
+        <p:nvSpPr>
+          <p:cNvPr id="19" name="Text 13"/>
+          <p:cNvSpPr/>
+          <p:nvPr/>
+        </p:nvSpPr>
+        <p:spPr>
+          <a:xfrm>
+            <a:off x="10497312" y="1234440"/>
+            <a:ext cx="960120" cy="1051560"/>
+          </a:xfrm>
+          <a:prstGeom prst="rect">
+            <a:avLst/>
+          </a:prstGeom>
+          <a:noFill/>
+          <a:ln/>
+        </p:spPr>
+        <p:txBody>
+          <a:bodyPr wrap="square" lIns="0" tIns="0" rIns="0" bIns="0" rtlCol="0" anchor="ctr"/>
+          <a:lstStyle/>
+          <a:p>
+            <a:pPr algn="l" indent="0" marL="0">
+              <a:buNone/>
+            </a:pPr>
+            <a:r>
+              <a:rPr lang="en-US" sz="1600" b="1" dirty="0">
+                <a:solidFill>
+                  <a:srgbClr val="E8722C"/>
+                </a:solidFill>
+                <a:latin typeface="Montserrat" pitchFamily="34" charset="0"/>
+                <a:ea typeface="Montserrat" pitchFamily="34" charset="-122"/>
+                <a:cs typeface="Montserrat" pitchFamily="34" charset="-120"/>
+              </a:rPr>
+              <a:t>SEE</a:t>
+            </a:r>
+            <a:endParaRPr lang="en-US" sz="1600" dirty="0"/>
+          </a:p>
+        </p:txBody>
+      </p:sp>
+      <p:sp>
+        <p:nvSpPr>
+          <p:cNvPr id="20" name="Text 14"/>
+          <p:cNvSpPr/>
+          <p:nvPr/>
+        </p:nvSpPr>
+        <p:spPr>
+          <a:xfrm>
+            <a:off x="9601200" y="2231136"/>
+            <a:ext cx="1965960" cy="457200"/>
           </a:xfrm>
           <a:prstGeom prst="rect">
             <a:avLst/>
@@ -2565,43 +2548,7 @@
               <a:buNone/>
             </a:pPr>
             <a:r>
-              <a:rPr lang="en-US" sz="3600" dirty="0">
-                <a:solidFill>
-                  <a:srgbClr val="000000"/>
-                </a:solidFill>
-              </a:rPr>
-              <a:t>👀</a:t>
-            </a:r>
-            <a:endParaRPr lang="en-US" sz="3600" dirty="0"/>
-          </a:p>
-        </p:txBody>
-      </p:sp>
-      <p:sp>
-        <p:nvSpPr>
-          <p:cNvPr id="18" name="Text 16"/>
-          <p:cNvSpPr/>
-          <p:nvPr/>
-        </p:nvSpPr>
-        <p:spPr>
-          <a:xfrm>
-            <a:off x="10424160" y="960120"/>
-            <a:ext cx="1005840" cy="1051560"/>
-          </a:xfrm>
-          <a:prstGeom prst="rect">
-            <a:avLst/>
-          </a:prstGeom>
-          <a:noFill/>
-          <a:ln/>
-        </p:spPr>
-        <p:txBody>
-          <a:bodyPr wrap="square" lIns="0" tIns="0" rIns="0" bIns="0" rtlCol="0" anchor="ctr"/>
-          <a:lstStyle/>
-          <a:p>
-            <a:pPr algn="l" indent="0" marL="0">
-              <a:buNone/>
-            </a:pPr>
-            <a:r>
-              <a:rPr lang="en-US" sz="1600" b="1" dirty="0">
+              <a:rPr lang="en-US" sz="2200" b="1" dirty="0">
                 <a:solidFill>
                   <a:srgbClr val="E8722C"/>
                 </a:solidFill>
@@ -2609,45 +2556,6 @@
                 <a:ea typeface="Montserrat" pitchFamily="34" charset="-122"/>
                 <a:cs typeface="Montserrat" pitchFamily="34" charset="-120"/>
               </a:rPr>
-              <a:t>SEE</a:t>
-            </a:r>
-            <a:endParaRPr lang="en-US" sz="1600" dirty="0"/>
-          </a:p>
-        </p:txBody>
-      </p:sp>
-      <p:sp>
-        <p:nvSpPr>
-          <p:cNvPr id="19" name="Text 17"/>
-          <p:cNvSpPr/>
-          <p:nvPr/>
-        </p:nvSpPr>
-        <p:spPr>
-          <a:xfrm>
-            <a:off x="9646920" y="1965960"/>
-            <a:ext cx="1828800" cy="457200"/>
-          </a:xfrm>
-          <a:prstGeom prst="rect">
-            <a:avLst/>
-          </a:prstGeom>
-          <a:noFill/>
-          <a:ln/>
-        </p:spPr>
-        <p:txBody>
-          <a:bodyPr wrap="square" lIns="0" tIns="0" rIns="0" bIns="0" rtlCol="0" anchor="ctr"/>
-          <a:lstStyle/>
-          <a:p>
-            <a:pPr algn="ctr" indent="0" marL="0">
-              <a:buNone/>
-            </a:pPr>
-            <a:r>
-              <a:rPr lang="en-US" sz="2200" b="1" dirty="0">
-                <a:solidFill>
-                  <a:srgbClr val="E8722C"/>
-                </a:solidFill>
-                <a:latin typeface="Montserrat" pitchFamily="34" charset="0"/>
-                <a:ea typeface="Montserrat" pitchFamily="34" charset="-122"/>
-                <a:cs typeface="Montserrat" pitchFamily="34" charset="-120"/>
-              </a:rPr>
               <a:t>↓</a:t>
             </a:r>
             <a:endParaRPr lang="en-US" sz="2200" dirty="0"/>
@@ -2656,14 +2564,14 @@
       </p:sp>
       <p:sp>
         <p:nvSpPr>
-          <p:cNvPr id="20" name="Shape 18"/>
-          <p:cNvSpPr/>
-          <p:nvPr/>
-        </p:nvSpPr>
-        <p:spPr>
-          <a:xfrm>
-            <a:off x="9646920" y="2377440"/>
-            <a:ext cx="1828800" cy="1051560"/>
+          <p:cNvPr id="21" name="Shape 15"/>
+          <p:cNvSpPr/>
+          <p:nvPr/>
+        </p:nvSpPr>
+        <p:spPr>
+          <a:xfrm>
+            <a:off x="9601200" y="2697480"/>
+            <a:ext cx="1965960" cy="1051560"/>
           </a:xfrm>
           <a:prstGeom prst="roundRect">
             <a:avLst>
@@ -2683,16 +2591,78 @@
           </a:effectLst>
         </p:spPr>
       </p:sp>
-      <p:sp>
-        <p:nvSpPr>
-          <p:cNvPr id="21" name="Text 19"/>
-          <p:cNvSpPr/>
-          <p:nvPr/>
-        </p:nvSpPr>
-        <p:spPr>
-          <a:xfrm>
-            <a:off x="9646920" y="2432304"/>
-            <a:ext cx="822960" cy="941832"/>
+      <p:pic>
+        <p:nvPicPr>
+          <p:cNvPr id="22" name="Image 3" descr="/home/user/Wristworkswebsite/presentation/icon_brain.png">    </p:cNvPr>
+          <p:cNvPicPr>
+            <a:picLocks noChangeAspect="1"/>
+          </p:cNvPicPr>
+          <p:nvPr/>
+        </p:nvPicPr>
+        <p:blipFill>
+          <a:blip r:embed="rId5"/>
+          <a:srcRect l="0" r="0" t="0" b="0"/>
+          <a:stretch/>
+        </p:blipFill>
+        <p:spPr>
+          <a:xfrm>
+            <a:off x="9747504" y="2880360"/>
+            <a:ext cx="685800" cy="685800"/>
+          </a:xfrm>
+          <a:prstGeom prst="rect">
+            <a:avLst/>
+          </a:prstGeom>
+        </p:spPr>
+      </p:pic>
+      <p:sp>
+        <p:nvSpPr>
+          <p:cNvPr id="23" name="Text 16"/>
+          <p:cNvSpPr/>
+          <p:nvPr/>
+        </p:nvSpPr>
+        <p:spPr>
+          <a:xfrm>
+            <a:off x="10497312" y="2697480"/>
+            <a:ext cx="960120" cy="1051560"/>
+          </a:xfrm>
+          <a:prstGeom prst="rect">
+            <a:avLst/>
+          </a:prstGeom>
+          <a:noFill/>
+          <a:ln/>
+        </p:spPr>
+        <p:txBody>
+          <a:bodyPr wrap="square" lIns="0" tIns="0" rIns="0" bIns="0" rtlCol="0" anchor="ctr"/>
+          <a:lstStyle/>
+          <a:p>
+            <a:pPr algn="l" indent="0" marL="0">
+              <a:buNone/>
+            </a:pPr>
+            <a:r>
+              <a:rPr lang="en-US" sz="1600" b="1" dirty="0">
+                <a:solidFill>
+                  <a:srgbClr val="D9433C"/>
+                </a:solidFill>
+                <a:latin typeface="Montserrat" pitchFamily="34" charset="0"/>
+                <a:ea typeface="Montserrat" pitchFamily="34" charset="-122"/>
+                <a:cs typeface="Montserrat" pitchFamily="34" charset="-120"/>
+              </a:rPr>
+              <a:t>EXPECT</a:t>
+            </a:r>
+            <a:endParaRPr lang="en-US" sz="1600" dirty="0"/>
+          </a:p>
+        </p:txBody>
+      </p:sp>
+      <p:sp>
+        <p:nvSpPr>
+          <p:cNvPr id="24" name="Text 17"/>
+          <p:cNvSpPr/>
+          <p:nvPr/>
+        </p:nvSpPr>
+        <p:spPr>
+          <a:xfrm>
+            <a:off x="9601200" y="3694176"/>
+            <a:ext cx="1965960" cy="457200"/>
           </a:xfrm>
           <a:prstGeom prst="rect">
             <a:avLst/>
@@ -2708,81 +2678,6 @@
               <a:buNone/>
             </a:pPr>
             <a:r>
-              <a:rPr lang="en-US" sz="3600" dirty="0">
-                <a:solidFill>
-                  <a:srgbClr val="000000"/>
-                </a:solidFill>
-              </a:rPr>
-              <a:t>🧠</a:t>
-            </a:r>
-            <a:endParaRPr lang="en-US" sz="3600" dirty="0"/>
-          </a:p>
-        </p:txBody>
-      </p:sp>
-      <p:sp>
-        <p:nvSpPr>
-          <p:cNvPr id="22" name="Text 20"/>
-          <p:cNvSpPr/>
-          <p:nvPr/>
-        </p:nvSpPr>
-        <p:spPr>
-          <a:xfrm>
-            <a:off x="10424160" y="2377440"/>
-            <a:ext cx="1005840" cy="1051560"/>
-          </a:xfrm>
-          <a:prstGeom prst="rect">
-            <a:avLst/>
-          </a:prstGeom>
-          <a:noFill/>
-          <a:ln/>
-        </p:spPr>
-        <p:txBody>
-          <a:bodyPr wrap="square" lIns="0" tIns="0" rIns="0" bIns="0" rtlCol="0" anchor="ctr"/>
-          <a:lstStyle/>
-          <a:p>
-            <a:pPr algn="l" indent="0" marL="0">
-              <a:buNone/>
-            </a:pPr>
-            <a:r>
-              <a:rPr lang="en-US" sz="1600" b="1" dirty="0">
-                <a:solidFill>
-                  <a:srgbClr val="D9433C"/>
-                </a:solidFill>
-                <a:latin typeface="Montserrat" pitchFamily="34" charset="0"/>
-                <a:ea typeface="Montserrat" pitchFamily="34" charset="-122"/>
-                <a:cs typeface="Montserrat" pitchFamily="34" charset="-120"/>
-              </a:rPr>
-              <a:t>EXPECT</a:t>
-            </a:r>
-            <a:endParaRPr lang="en-US" sz="1600" dirty="0"/>
-          </a:p>
-        </p:txBody>
-      </p:sp>
-      <p:sp>
-        <p:nvSpPr>
-          <p:cNvPr id="23" name="Text 21"/>
-          <p:cNvSpPr/>
-          <p:nvPr/>
-        </p:nvSpPr>
-        <p:spPr>
-          <a:xfrm>
-            <a:off x="9646920" y="3383280"/>
-            <a:ext cx="1828800" cy="457200"/>
-          </a:xfrm>
-          <a:prstGeom prst="rect">
-            <a:avLst/>
-          </a:prstGeom>
-          <a:noFill/>
-          <a:ln/>
-        </p:spPr>
-        <p:txBody>
-          <a:bodyPr wrap="square" lIns="0" tIns="0" rIns="0" bIns="0" rtlCol="0" anchor="ctr"/>
-          <a:lstStyle/>
-          <a:p>
-            <a:pPr algn="ctr" indent="0" marL="0">
-              <a:buNone/>
-            </a:pPr>
-            <a:r>
               <a:rPr lang="en-US" sz="2200" b="1" dirty="0">
                 <a:solidFill>
                   <a:srgbClr val="E8722C"/>
@@ -2799,14 +2694,14 @@
       </p:sp>
       <p:sp>
         <p:nvSpPr>
-          <p:cNvPr id="24" name="Shape 22"/>
-          <p:cNvSpPr/>
-          <p:nvPr/>
-        </p:nvSpPr>
-        <p:spPr>
-          <a:xfrm>
-            <a:off x="9646920" y="3794760"/>
-            <a:ext cx="1828800" cy="1051560"/>
+          <p:cNvPr id="25" name="Shape 18"/>
+          <p:cNvSpPr/>
+          <p:nvPr/>
+        </p:nvSpPr>
+        <p:spPr>
+          <a:xfrm>
+            <a:off x="9601200" y="4160520"/>
+            <a:ext cx="1965960" cy="1051560"/>
           </a:xfrm>
           <a:prstGeom prst="roundRect">
             <a:avLst>
@@ -2826,52 +2721,39 @@
           </a:effectLst>
         </p:spPr>
       </p:sp>
-      <p:sp>
-        <p:nvSpPr>
-          <p:cNvPr id="25" name="Text 23"/>
-          <p:cNvSpPr/>
-          <p:nvPr/>
-        </p:nvSpPr>
-        <p:spPr>
-          <a:xfrm>
-            <a:off x="9646920" y="3849624"/>
-            <a:ext cx="822960" cy="941832"/>
-          </a:xfrm>
-          <a:prstGeom prst="rect">
-            <a:avLst/>
-          </a:prstGeom>
-          <a:noFill/>
-          <a:ln/>
-        </p:spPr>
-        <p:txBody>
-          <a:bodyPr wrap="square" lIns="0" tIns="0" rIns="0" bIns="0" rtlCol="0" anchor="ctr"/>
-          <a:lstStyle/>
-          <a:p>
-            <a:pPr algn="ctr" indent="0" marL="0">
-              <a:buNone/>
-            </a:pPr>
-            <a:r>
-              <a:rPr lang="en-US" sz="3600" dirty="0">
-                <a:solidFill>
-                  <a:srgbClr val="000000"/>
-                </a:solidFill>
-              </a:rPr>
-              <a:t>🍴</a:t>
-            </a:r>
-            <a:endParaRPr lang="en-US" sz="3600" dirty="0"/>
-          </a:p>
-        </p:txBody>
-      </p:sp>
-      <p:sp>
-        <p:nvSpPr>
-          <p:cNvPr id="26" name="Text 24"/>
-          <p:cNvSpPr/>
-          <p:nvPr/>
-        </p:nvSpPr>
-        <p:spPr>
-          <a:xfrm>
-            <a:off x="10424160" y="3794760"/>
-            <a:ext cx="1005840" cy="1051560"/>
+      <p:pic>
+        <p:nvPicPr>
+          <p:cNvPr id="26" name="Image 4" descr="/home/user/Wristworkswebsite/presentation/icon_fork.png">    </p:cNvPr>
+          <p:cNvPicPr>
+            <a:picLocks noChangeAspect="1"/>
+          </p:cNvPicPr>
+          <p:nvPr/>
+        </p:nvPicPr>
+        <p:blipFill>
+          <a:blip r:embed="rId6"/>
+          <a:srcRect l="0" r="0" t="0" b="0"/>
+          <a:stretch/>
+        </p:blipFill>
+        <p:spPr>
+          <a:xfrm>
+            <a:off x="9747504" y="4343400"/>
+            <a:ext cx="685800" cy="685800"/>
+          </a:xfrm>
+          <a:prstGeom prst="rect">
+            <a:avLst/>
+          </a:prstGeom>
+        </p:spPr>
+      </p:pic>
+      <p:sp>
+        <p:nvSpPr>
+          <p:cNvPr id="27" name="Text 19"/>
+          <p:cNvSpPr/>
+          <p:nvPr/>
+        </p:nvSpPr>
+        <p:spPr>
+          <a:xfrm>
+            <a:off x="10497312" y="4160520"/>
+            <a:ext cx="960120" cy="1051560"/>
           </a:xfrm>
           <a:prstGeom prst="rect">
             <a:avLst/>
@@ -2903,13 +2785,13 @@
       </p:sp>
       <p:sp>
         <p:nvSpPr>
-          <p:cNvPr id="27" name="Text 25"/>
-          <p:cNvSpPr/>
-          <p:nvPr/>
-        </p:nvSpPr>
-        <p:spPr>
-          <a:xfrm>
-            <a:off x="685800" y="5257800"/>
+          <p:cNvPr id="28" name="Text 20"/>
+          <p:cNvSpPr/>
+          <p:nvPr/>
+        </p:nvSpPr>
+        <p:spPr>
+          <a:xfrm>
+            <a:off x="685800" y="5349240"/>
             <a:ext cx="8595360" cy="548640"/>
           </a:xfrm>
           <a:prstGeom prst="rect">
@@ -2981,7 +2863,7 @@
       </p:grpSpPr>
       <p:sp>
         <p:nvSpPr>
-          <p:cNvPr id="2" name="Shape 0"/>
+          <p:cNvPr id="3" name="Shape 0"/>
           <p:cNvSpPr/>
           <p:nvPr/>
         </p:nvSpPr>
@@ -3003,7 +2885,7 @@
       </p:sp>
       <p:sp>
         <p:nvSpPr>
-          <p:cNvPr id="3" name="Text 1"/>
+          <p:cNvPr id="4" name="Text 1"/>
           <p:cNvSpPr/>
           <p:nvPr/>
         </p:nvSpPr>
@@ -3042,14 +2924,14 @@
       </p:sp>
       <p:sp>
         <p:nvSpPr>
-          <p:cNvPr id="4" name="Text 2"/>
+          <p:cNvPr id="5" name="Text 2"/>
           <p:cNvSpPr/>
           <p:nvPr/>
         </p:nvSpPr>
         <p:spPr>
           <a:xfrm>
             <a:off x="640080" y="1051560"/>
-            <a:ext cx="11338560" cy="822960"/>
+            <a:ext cx="10424160" cy="822960"/>
           </a:xfrm>
           <a:prstGeom prst="rect">
             <a:avLst/>
@@ -3095,7 +2977,7 @@
       </p:sp>
       <p:sp>
         <p:nvSpPr>
-          <p:cNvPr id="5" name="Shape 3"/>
+          <p:cNvPr id="6" name="Shape 3"/>
           <p:cNvSpPr/>
           <p:nvPr/>
         </p:nvSpPr>
@@ -3129,7 +3011,7 @@
       </p:sp>
       <p:sp>
         <p:nvSpPr>
-          <p:cNvPr id="6" name="Text 4"/>
+          <p:cNvPr id="7" name="Text 4"/>
           <p:cNvSpPr/>
           <p:nvPr/>
         </p:nvSpPr>
@@ -3168,7 +3050,7 @@
       </p:sp>
       <p:sp>
         <p:nvSpPr>
-          <p:cNvPr id="7" name="Text 5"/>
+          <p:cNvPr id="8" name="Text 5"/>
           <p:cNvSpPr/>
           <p:nvPr/>
         </p:nvSpPr>
@@ -3207,7 +3089,7 @@
       </p:sp>
       <p:sp>
         <p:nvSpPr>
-          <p:cNvPr id="8" name="Text 6"/>
+          <p:cNvPr id="9" name="Text 6"/>
           <p:cNvSpPr/>
           <p:nvPr/>
         </p:nvSpPr>
@@ -3246,7 +3128,7 @@
       </p:sp>
       <p:sp>
         <p:nvSpPr>
-          <p:cNvPr id="9" name="Text 7"/>
+          <p:cNvPr id="10" name="Text 7"/>
           <p:cNvSpPr/>
           <p:nvPr/>
         </p:nvSpPr>
@@ -3285,7 +3167,7 @@
       </p:sp>
       <p:sp>
         <p:nvSpPr>
-          <p:cNvPr id="10" name="Shape 8"/>
+          <p:cNvPr id="11" name="Shape 8"/>
           <p:cNvSpPr/>
           <p:nvPr/>
         </p:nvSpPr>
@@ -3308,7 +3190,7 @@
       </p:sp>
       <p:sp>
         <p:nvSpPr>
-          <p:cNvPr id="11" name="Text 9"/>
+          <p:cNvPr id="12" name="Text 9"/>
           <p:cNvSpPr/>
           <p:nvPr/>
         </p:nvSpPr>
@@ -3347,14 +3229,14 @@
       </p:sp>
       <p:sp>
         <p:nvSpPr>
-          <p:cNvPr id="12" name="Text 10"/>
+          <p:cNvPr id="13" name="Text 10"/>
           <p:cNvSpPr/>
           <p:nvPr/>
         </p:nvSpPr>
         <p:spPr>
           <a:xfrm>
             <a:off x="1188720" y="4352544"/>
-            <a:ext cx="4937760" cy="566928"/>
+            <a:ext cx="4434840" cy="566928"/>
           </a:xfrm>
           <a:prstGeom prst="rect">
             <a:avLst/>
@@ -3386,7 +3268,7 @@
       </p:sp>
       <p:sp>
         <p:nvSpPr>
-          <p:cNvPr id="13" name="Text 11"/>
+          <p:cNvPr id="14" name="Text 11"/>
           <p:cNvSpPr/>
           <p:nvPr/>
         </p:nvSpPr>
@@ -3425,7 +3307,46 @@
       </p:sp>
       <p:sp>
         <p:nvSpPr>
-          <p:cNvPr id="14" name="Shape 12"/>
+          <p:cNvPr id="15" name="Text 12"/>
+          <p:cNvSpPr/>
+          <p:nvPr/>
+        </p:nvSpPr>
+        <p:spPr>
+          <a:xfrm>
+            <a:off x="5760720" y="4443984"/>
+            <a:ext cx="1600200" cy="320040"/>
+          </a:xfrm>
+          <a:prstGeom prst="rect">
+            <a:avLst/>
+          </a:prstGeom>
+          <a:noFill/>
+          <a:ln/>
+        </p:spPr>
+        <p:txBody>
+          <a:bodyPr wrap="square" lIns="0" tIns="0" rIns="0" bIns="0" rtlCol="0" anchor="ctr"/>
+          <a:lstStyle/>
+          <a:p>
+            <a:pPr algn="r" indent="0" marL="0">
+              <a:buNone/>
+            </a:pPr>
+            <a:r>
+              <a:rPr lang="en-US" sz="1150" i="1" dirty="0">
+                <a:solidFill>
+                  <a:srgbClr val="E8722C"/>
+                </a:solidFill>
+                <a:latin typeface="Calibri" pitchFamily="34" charset="0"/>
+                <a:ea typeface="Calibri" pitchFamily="34" charset="-122"/>
+                <a:cs typeface="Calibri" pitchFamily="34" charset="-120"/>
+              </a:rPr>
+              <a:t>🔥 most ordered</a:t>
+            </a:r>
+            <a:endParaRPr lang="en-US" sz="1150" dirty="0"/>
+          </a:p>
+        </p:txBody>
+      </p:sp>
+      <p:sp>
+        <p:nvSpPr>
+          <p:cNvPr id="16" name="Shape 13"/>
           <p:cNvSpPr/>
           <p:nvPr/>
         </p:nvSpPr>
@@ -3448,7 +3369,7 @@
       </p:sp>
       <p:sp>
         <p:nvSpPr>
-          <p:cNvPr id="15" name="Text 13"/>
+          <p:cNvPr id="17" name="Text 14"/>
           <p:cNvSpPr/>
           <p:nvPr/>
         </p:nvSpPr>
@@ -3487,7 +3408,7 @@
       </p:sp>
       <p:sp>
         <p:nvSpPr>
-          <p:cNvPr id="16" name="Text 14"/>
+          <p:cNvPr id="18" name="Text 15"/>
           <p:cNvSpPr/>
           <p:nvPr/>
         </p:nvSpPr>
@@ -3526,135 +3447,119 @@
       </p:sp>
       <p:sp>
         <p:nvSpPr>
-          <p:cNvPr id="17" name="Text 15"/>
-          <p:cNvSpPr/>
-          <p:nvPr/>
-        </p:nvSpPr>
-        <p:spPr>
-          <a:xfrm>
-            <a:off x="5440680" y="4407408"/>
-            <a:ext cx="1737360" cy="320040"/>
-          </a:xfrm>
-          <a:prstGeom prst="rect">
-            <a:avLst/>
-          </a:prstGeom>
-          <a:noFill/>
-          <a:ln/>
-        </p:spPr>
-        <p:txBody>
-          <a:bodyPr wrap="square" lIns="0" tIns="0" rIns="0" bIns="0" rtlCol="0" anchor="ctr"/>
-          <a:lstStyle/>
-          <a:p>
-            <a:pPr algn="r" indent="0" marL="0">
-              <a:buNone/>
-            </a:pPr>
-            <a:r>
-              <a:rPr lang="en-US" sz="1150" i="1" dirty="0">
-                <a:solidFill>
-                  <a:srgbClr val="E8722C"/>
+          <p:cNvPr id="19" name="Text 16"/>
+          <p:cNvSpPr/>
+          <p:nvPr/>
+        </p:nvSpPr>
+        <p:spPr>
+          <a:xfrm>
+            <a:off x="7955280" y="2057400"/>
+            <a:ext cx="4023360" cy="868680"/>
+          </a:xfrm>
+          <a:prstGeom prst="rect">
+            <a:avLst/>
+          </a:prstGeom>
+          <a:noFill/>
+          <a:ln/>
+        </p:spPr>
+        <p:txBody>
+          <a:bodyPr wrap="square" lIns="0" tIns="0" rIns="0" bIns="0" rtlCol="0" anchor="ctr"/>
+          <a:lstStyle/>
+          <a:p>
+            <a:pPr indent="0" marL="0">
+              <a:buNone/>
+            </a:pPr>
+            <a:r>
+              <a:rPr lang="en-US" sz="2400" b="1" dirty="0">
+                <a:solidFill>
+                  <a:srgbClr val="2B1B14"/>
+                </a:solidFill>
+                <a:latin typeface="Montserrat" pitchFamily="34" charset="0"/>
+                <a:ea typeface="Montserrat" pitchFamily="34" charset="-122"/>
+                <a:cs typeface="Montserrat" pitchFamily="34" charset="-120"/>
+              </a:rPr>
+              <a:t>Which one would you order?</a:t>
+            </a:r>
+            <a:endParaRPr lang="en-US" sz="2400" dirty="0"/>
+          </a:p>
+        </p:txBody>
+      </p:sp>
+      <p:pic>
+        <p:nvPicPr>
+          <p:cNvPr id="20" name="Image 0" descr="/home/user/Wristworkswebsite/presentation/art_burger.png">    </p:cNvPr>
+          <p:cNvPicPr>
+            <a:picLocks noChangeAspect="1"/>
+          </p:cNvPicPr>
+          <p:nvPr/>
+        </p:nvPicPr>
+        <p:blipFill>
+          <a:blip r:embed="rId2"/>
+          <a:srcRect l="0" r="0" t="0" b="0"/>
+          <a:stretch/>
+        </p:blipFill>
+        <p:spPr>
+          <a:xfrm>
+            <a:off x="8732520" y="2880360"/>
+            <a:ext cx="2423160" cy="1691640"/>
+          </a:xfrm>
+          <a:prstGeom prst="rect">
+            <a:avLst/>
+          </a:prstGeom>
+        </p:spPr>
+      </p:pic>
+      <p:sp>
+        <p:nvSpPr>
+          <p:cNvPr id="21" name="Text 17"/>
+          <p:cNvSpPr/>
+          <p:nvPr/>
+        </p:nvSpPr>
+        <p:spPr>
+          <a:xfrm>
+            <a:off x="7955280" y="4590288"/>
+            <a:ext cx="4023360" cy="411480"/>
+          </a:xfrm>
+          <a:prstGeom prst="rect">
+            <a:avLst/>
+          </a:prstGeom>
+          <a:noFill/>
+          <a:ln/>
+        </p:spPr>
+        <p:txBody>
+          <a:bodyPr wrap="square" lIns="0" tIns="0" rIns="0" bIns="0" rtlCol="0" anchor="ctr"/>
+          <a:lstStyle/>
+          <a:p>
+            <a:pPr algn="ctr" indent="0" marL="0">
+              <a:buNone/>
+            </a:pPr>
+            <a:r>
+              <a:rPr lang="en-US" sz="1600" i="1" dirty="0">
+                <a:solidFill>
+                  <a:srgbClr val="D9433C"/>
                 </a:solidFill>
                 <a:latin typeface="Calibri" pitchFamily="34" charset="0"/>
                 <a:ea typeface="Calibri" pitchFamily="34" charset="-122"/>
                 <a:cs typeface="Calibri" pitchFamily="34" charset="-120"/>
               </a:rPr>
-              <a:t>🔥 most ordered</a:t>
-            </a:r>
-            <a:endParaRPr lang="en-US" sz="1150" dirty="0"/>
-          </a:p>
-        </p:txBody>
-      </p:sp>
-      <p:sp>
-        <p:nvSpPr>
-          <p:cNvPr id="18" name="Text 16"/>
-          <p:cNvSpPr/>
-          <p:nvPr/>
-        </p:nvSpPr>
-        <p:spPr>
-          <a:xfrm>
-            <a:off x="8001000" y="2148840"/>
-            <a:ext cx="3931920" cy="914400"/>
-          </a:xfrm>
-          <a:prstGeom prst="rect">
-            <a:avLst/>
-          </a:prstGeom>
-          <a:noFill/>
-          <a:ln/>
-        </p:spPr>
-        <p:txBody>
-          <a:bodyPr wrap="square" lIns="0" tIns="0" rIns="0" bIns="0" rtlCol="0" anchor="ctr"/>
-          <a:lstStyle/>
-          <a:p>
-            <a:pPr indent="0" marL="0">
-              <a:buNone/>
-            </a:pPr>
-            <a:r>
-              <a:rPr lang="en-US" sz="2600" b="1" dirty="0">
-                <a:solidFill>
-                  <a:srgbClr val="2B1B14"/>
-                </a:solidFill>
-                <a:latin typeface="Montserrat" pitchFamily="34" charset="0"/>
-                <a:ea typeface="Montserrat" pitchFamily="34" charset="-122"/>
-                <a:cs typeface="Montserrat" pitchFamily="34" charset="-120"/>
-              </a:rPr>
-              <a:t>Which one would you order?</a:t>
-            </a:r>
-            <a:endParaRPr lang="en-US" sz="2600" dirty="0"/>
-          </a:p>
-        </p:txBody>
-      </p:sp>
-      <p:sp>
-        <p:nvSpPr>
-          <p:cNvPr id="19" name="Text 17"/>
-          <p:cNvSpPr/>
-          <p:nvPr/>
-        </p:nvSpPr>
-        <p:spPr>
-          <a:xfrm>
-            <a:off x="8028432" y="3063240"/>
-            <a:ext cx="3840480" cy="457200"/>
-          </a:xfrm>
-          <a:prstGeom prst="rect">
-            <a:avLst/>
-          </a:prstGeom>
-          <a:noFill/>
-          <a:ln/>
-        </p:spPr>
-        <p:txBody>
-          <a:bodyPr wrap="square" lIns="0" tIns="0" rIns="0" bIns="0" rtlCol="0" anchor="ctr"/>
-          <a:lstStyle/>
-          <a:p>
-            <a:pPr indent="0" marL="0">
-              <a:buNone/>
-            </a:pPr>
-            <a:r>
-              <a:rPr lang="en-US" sz="1700" i="1" dirty="0">
-                <a:solidFill>
-                  <a:srgbClr val="D9433C"/>
-                </a:solidFill>
-                <a:latin typeface="Calibri" pitchFamily="34" charset="0"/>
-                <a:ea typeface="Calibri" pitchFamily="34" charset="-122"/>
-                <a:cs typeface="Calibri" pitchFamily="34" charset="-120"/>
-              </a:rPr>
               <a:t>Same beef. Different words.</a:t>
             </a:r>
-            <a:endParaRPr lang="en-US" sz="1700" dirty="0"/>
-          </a:p>
-        </p:txBody>
-      </p:sp>
-      <p:sp>
-        <p:nvSpPr>
-          <p:cNvPr id="20" name="Shape 18"/>
-          <p:cNvSpPr/>
-          <p:nvPr/>
-        </p:nvSpPr>
-        <p:spPr>
-          <a:xfrm>
-            <a:off x="8001000" y="3840480"/>
-            <a:ext cx="3931920" cy="1874520"/>
+            <a:endParaRPr lang="en-US" sz="1600" dirty="0"/>
+          </a:p>
+        </p:txBody>
+      </p:sp>
+      <p:sp>
+        <p:nvSpPr>
+          <p:cNvPr id="22" name="Shape 18"/>
+          <p:cNvSpPr/>
+          <p:nvPr/>
+        </p:nvSpPr>
+        <p:spPr>
+          <a:xfrm>
+            <a:off x="7955280" y="5074920"/>
+            <a:ext cx="4023360" cy="1097280"/>
           </a:xfrm>
           <a:prstGeom prst="roundRect">
             <a:avLst>
-              <a:gd name="adj" fmla="val 8780"/>
+              <a:gd name="adj" fmla="val 13333"/>
             </a:avLst>
           </a:prstGeom>
           <a:solidFill>
@@ -3662,7 +3567,7 @@
           </a:solidFill>
           <a:ln/>
           <a:effectLst>
-            <a:outerShdw sx="100000" sy="100000" kx="0" ky="0" algn="bl" rotWithShape="0" blurRad="177800" dist="63500" dir="5400000">
+            <a:outerShdw sx="100000" sy="100000" kx="0" ky="0" algn="bl" rotWithShape="0" blurRad="152400" dist="50800" dir="5400000">
               <a:srgbClr val="7a3b1d">
                 <a:alpha val="50000"/>
               </a:srgbClr>
@@ -3672,69 +3577,30 @@
       </p:sp>
       <p:sp>
         <p:nvSpPr>
-          <p:cNvPr id="21" name="Text 19"/>
-          <p:cNvSpPr/>
-          <p:nvPr/>
-        </p:nvSpPr>
-        <p:spPr>
-          <a:xfrm>
-            <a:off x="8229600" y="4041648"/>
-            <a:ext cx="3474720" cy="365760"/>
-          </a:xfrm>
-          <a:prstGeom prst="rect">
-            <a:avLst/>
-          </a:prstGeom>
-          <a:noFill/>
-          <a:ln/>
-        </p:spPr>
-        <p:txBody>
-          <a:bodyPr wrap="square" lIns="0" tIns="0" rIns="0" bIns="0" rtlCol="0" anchor="ctr"/>
-          <a:lstStyle/>
-          <a:p>
-            <a:pPr indent="0" marL="0">
-              <a:buNone/>
-            </a:pPr>
-            <a:r>
-              <a:rPr lang="en-US" sz="1400" b="1" spc="200" kern="0" dirty="0">
-                <a:solidFill>
-                  <a:srgbClr val="F0A868"/>
-                </a:solidFill>
-                <a:latin typeface="Montserrat" pitchFamily="34" charset="0"/>
-                <a:ea typeface="Montserrat" pitchFamily="34" charset="-122"/>
-                <a:cs typeface="Montserrat" pitchFamily="34" charset="-120"/>
-              </a:rPr>
-              <a:t>THE RECIPE FOR 'YES'</a:t>
-            </a:r>
-            <a:endParaRPr lang="en-US" sz="1400" dirty="0"/>
-          </a:p>
-        </p:txBody>
-      </p:sp>
-      <p:sp>
-        <p:nvSpPr>
-          <p:cNvPr id="22" name="Text 20"/>
-          <p:cNvSpPr/>
-          <p:nvPr/>
-        </p:nvSpPr>
-        <p:spPr>
-          <a:xfrm>
-            <a:off x="8229600" y="4498848"/>
-            <a:ext cx="3520440" cy="548640"/>
-          </a:xfrm>
-          <a:prstGeom prst="rect">
-            <a:avLst/>
-          </a:prstGeom>
-          <a:noFill/>
-          <a:ln/>
-        </p:spPr>
-        <p:txBody>
-          <a:bodyPr wrap="square" lIns="0" tIns="0" rIns="0" bIns="0" rtlCol="0" anchor="ctr"/>
-          <a:lstStyle/>
-          <a:p>
-            <a:pPr indent="0" marL="0">
-              <a:buNone/>
-            </a:pPr>
-            <a:r>
-              <a:rPr lang="en-US" sz="1700" b="1" dirty="0">
+          <p:cNvPr id="23" name="Text 19"/>
+          <p:cNvSpPr/>
+          <p:nvPr/>
+        </p:nvSpPr>
+        <p:spPr>
+          <a:xfrm>
+            <a:off x="8138160" y="5212080"/>
+            <a:ext cx="3657600" cy="457200"/>
+          </a:xfrm>
+          <a:prstGeom prst="rect">
+            <a:avLst/>
+          </a:prstGeom>
+          <a:noFill/>
+          <a:ln/>
+        </p:spPr>
+        <p:txBody>
+          <a:bodyPr wrap="square" lIns="0" tIns="0" rIns="0" bIns="0" rtlCol="0" anchor="ctr"/>
+          <a:lstStyle/>
+          <a:p>
+            <a:pPr algn="ctr" indent="0" marL="0">
+              <a:buNone/>
+            </a:pPr>
+            <a:r>
+              <a:rPr lang="en-US" sz="1500" b="1" dirty="0">
                 <a:solidFill>
                   <a:srgbClr val="FDF6EC"/>
                 </a:solidFill>
@@ -3742,13 +3608,13 @@
                 <a:ea typeface="Montserrat" pitchFamily="34" charset="-122"/>
                 <a:cs typeface="Montserrat" pitchFamily="34" charset="-120"/>
               </a:rPr>
-              <a:t>Words</a:t>
-            </a:r>
-            <a:pPr indent="0" marL="0">
-              <a:buNone/>
-            </a:pPr>
-            <a:r>
-              <a:rPr lang="en-US" sz="1700" b="1" dirty="0">
+              <a:t>Words </a:t>
+            </a:r>
+            <a:pPr algn="ctr" indent="0" marL="0">
+              <a:buNone/>
+            </a:pPr>
+            <a:r>
+              <a:rPr lang="en-US" sz="1500" b="1" dirty="0">
                 <a:solidFill>
                   <a:srgbClr val="E8722C"/>
                 </a:solidFill>
@@ -3756,13 +3622,13 @@
                 <a:ea typeface="Montserrat" pitchFamily="34" charset="-122"/>
                 <a:cs typeface="Montserrat" pitchFamily="34" charset="-120"/>
               </a:rPr>
-              <a:t>  +  </a:t>
-            </a:r>
-            <a:pPr indent="0" marL="0">
-              <a:buNone/>
-            </a:pPr>
-            <a:r>
-              <a:rPr lang="en-US" sz="1700" b="1" dirty="0">
+              <a:t>+ </a:t>
+            </a:r>
+            <a:pPr algn="ctr" indent="0" marL="0">
+              <a:buNone/>
+            </a:pPr>
+            <a:r>
+              <a:rPr lang="en-US" sz="1500" b="1" dirty="0">
                 <a:solidFill>
                   <a:srgbClr val="FDF6EC"/>
                 </a:solidFill>
@@ -3770,13 +3636,13 @@
                 <a:ea typeface="Montserrat" pitchFamily="34" charset="-122"/>
                 <a:cs typeface="Montserrat" pitchFamily="34" charset="-120"/>
               </a:rPr>
-              <a:t>Layout</a:t>
-            </a:r>
-            <a:pPr indent="0" marL="0">
-              <a:buNone/>
-            </a:pPr>
-            <a:r>
-              <a:rPr lang="en-US" sz="1700" b="1" dirty="0">
+              <a:t>Layout </a:t>
+            </a:r>
+            <a:pPr algn="ctr" indent="0" marL="0">
+              <a:buNone/>
+            </a:pPr>
+            <a:r>
+              <a:rPr lang="en-US" sz="1500" b="1" dirty="0">
                 <a:solidFill>
                   <a:srgbClr val="E8722C"/>
                 </a:solidFill>
@@ -3784,13 +3650,13 @@
                 <a:ea typeface="Montserrat" pitchFamily="34" charset="-122"/>
                 <a:cs typeface="Montserrat" pitchFamily="34" charset="-120"/>
               </a:rPr>
-              <a:t>  +  </a:t>
-            </a:r>
-            <a:pPr indent="0" marL="0">
-              <a:buNone/>
-            </a:pPr>
-            <a:r>
-              <a:rPr lang="en-US" sz="1700" b="1" dirty="0">
+              <a:t>+ </a:t>
+            </a:r>
+            <a:pPr algn="ctr" indent="0" marL="0">
+              <a:buNone/>
+            </a:pPr>
+            <a:r>
+              <a:rPr lang="en-US" sz="1500" b="1" dirty="0">
                 <a:solidFill>
                   <a:srgbClr val="FDF6EC"/>
                 </a:solidFill>
@@ -3800,36 +3666,36 @@
               </a:rPr>
               <a:t>Presentation</a:t>
             </a:r>
-            <a:endParaRPr lang="en-US" sz="1700" dirty="0"/>
-          </a:p>
-        </p:txBody>
-      </p:sp>
-      <p:sp>
-        <p:nvSpPr>
-          <p:cNvPr id="23" name="Text 21"/>
-          <p:cNvSpPr/>
-          <p:nvPr/>
-        </p:nvSpPr>
-        <p:spPr>
-          <a:xfrm>
-            <a:off x="8229600" y="5074920"/>
-            <a:ext cx="3474720" cy="502920"/>
-          </a:xfrm>
-          <a:prstGeom prst="rect">
-            <a:avLst/>
-          </a:prstGeom>
-          <a:noFill/>
-          <a:ln/>
-        </p:spPr>
-        <p:txBody>
-          <a:bodyPr wrap="square" lIns="0" tIns="0" rIns="0" bIns="0" rtlCol="0" anchor="ctr"/>
-          <a:lstStyle/>
-          <a:p>
-            <a:pPr indent="0" marL="0">
-              <a:buNone/>
-            </a:pPr>
-            <a:r>
-              <a:rPr lang="en-US" sz="2200" b="1" dirty="0">
+            <a:endParaRPr lang="en-US" sz="1500" dirty="0"/>
+          </a:p>
+        </p:txBody>
+      </p:sp>
+      <p:sp>
+        <p:nvSpPr>
+          <p:cNvPr id="24" name="Text 20"/>
+          <p:cNvSpPr/>
+          <p:nvPr/>
+        </p:nvSpPr>
+        <p:spPr>
+          <a:xfrm>
+            <a:off x="8138160" y="5623560"/>
+            <a:ext cx="3657600" cy="457200"/>
+          </a:xfrm>
+          <a:prstGeom prst="rect">
+            <a:avLst/>
+          </a:prstGeom>
+          <a:noFill/>
+          <a:ln/>
+        </p:spPr>
+        <p:txBody>
+          <a:bodyPr wrap="square" lIns="0" tIns="0" rIns="0" bIns="0" rtlCol="0" anchor="ctr"/>
+          <a:lstStyle/>
+          <a:p>
+            <a:pPr algn="ctr" indent="0" marL="0">
+              <a:buNone/>
+            </a:pPr>
+            <a:r>
+              <a:rPr lang="en-US" sz="2100" b="1" dirty="0">
                 <a:solidFill>
                   <a:srgbClr val="E8722C"/>
                 </a:solidFill>
@@ -3839,7 +3705,7 @@
               </a:rPr>
               <a:t>= influence 🍴</a:t>
             </a:r>
-            <a:endParaRPr lang="en-US" sz="2200" dirty="0"/>
+            <a:endParaRPr lang="en-US" sz="2100" dirty="0"/>
           </a:p>
         </p:txBody>
       </p:sp>
@@ -3884,7 +3750,7 @@
       </p:grpSpPr>
       <p:sp>
         <p:nvSpPr>
-          <p:cNvPr id="2" name="Shape 0"/>
+          <p:cNvPr id="3" name="Shape 0"/>
           <p:cNvSpPr/>
           <p:nvPr/>
         </p:nvSpPr>
@@ -3906,7 +3772,7 @@
       </p:sp>
       <p:sp>
         <p:nvSpPr>
-          <p:cNvPr id="3" name="Text 1"/>
+          <p:cNvPr id="4" name="Text 1"/>
           <p:cNvSpPr/>
           <p:nvPr/>
         </p:nvSpPr>
@@ -3945,7 +3811,7 @@
       </p:sp>
       <p:sp>
         <p:nvSpPr>
-          <p:cNvPr id="4" name="Text 2"/>
+          <p:cNvPr id="5" name="Text 2"/>
           <p:cNvSpPr/>
           <p:nvPr/>
         </p:nvSpPr>
@@ -3998,18 +3864,18 @@
       </p:sp>
       <p:sp>
         <p:nvSpPr>
-          <p:cNvPr id="5" name="Shape 3"/>
+          <p:cNvPr id="6" name="Shape 3"/>
           <p:cNvSpPr/>
           <p:nvPr/>
         </p:nvSpPr>
         <p:spPr>
           <a:xfrm>
             <a:off x="685800" y="2148840"/>
-            <a:ext cx="1938528" cy="2148840"/>
+            <a:ext cx="1938528" cy="2194560"/>
           </a:xfrm>
           <a:prstGeom prst="roundRect">
             <a:avLst>
-              <a:gd name="adj" fmla="val 9434"/>
+              <a:gd name="adj" fmla="val 7547"/>
             </a:avLst>
           </a:prstGeom>
           <a:solidFill>
@@ -4018,23 +3884,46 @@
           <a:ln/>
           <a:effectLst>
             <a:outerShdw sx="100000" sy="100000" kx="0" ky="0" algn="bl" rotWithShape="0" blurRad="177800" dist="76200" dir="5400000">
-              <a:srgbClr val="3d1810">
+              <a:srgbClr val="1C1109">
                 <a:alpha val="50000"/>
               </a:srgbClr>
             </a:outerShdw>
           </a:effectLst>
         </p:spPr>
       </p:sp>
-      <p:sp>
-        <p:nvSpPr>
-          <p:cNvPr id="6" name="Text 4"/>
-          <p:cNvSpPr/>
-          <p:nvPr/>
-        </p:nvSpPr>
-        <p:spPr>
-          <a:xfrm>
-            <a:off x="685800" y="2286000"/>
-            <a:ext cx="1938528" cy="1234440"/>
+      <p:pic>
+        <p:nvPicPr>
+          <p:cNvPr id="7" name="Image 0" descr="/home/user/Wristworkswebsite/presentation/art_family.png">    </p:cNvPr>
+          <p:cNvPicPr>
+            <a:picLocks noChangeAspect="1"/>
+          </p:cNvPicPr>
+          <p:nvPr/>
+        </p:nvPicPr>
+        <p:blipFill>
+          <a:blip r:embed="rId2"/>
+          <a:srcRect l="0" r="0" t="0" b="0"/>
+          <a:stretch/>
+        </p:blipFill>
+        <p:spPr>
+          <a:xfrm>
+            <a:off x="813816" y="2276856"/>
+            <a:ext cx="1682496" cy="1645920"/>
+          </a:xfrm>
+          <a:prstGeom prst="rect">
+            <a:avLst/>
+          </a:prstGeom>
+        </p:spPr>
+      </p:pic>
+      <p:sp>
+        <p:nvSpPr>
+          <p:cNvPr id="8" name="Text 4"/>
+          <p:cNvSpPr/>
+          <p:nvPr/>
+        </p:nvSpPr>
+        <p:spPr>
+          <a:xfrm>
+            <a:off x="685800" y="3959352"/>
+            <a:ext cx="1938528" cy="329184"/>
           </a:xfrm>
           <a:prstGeom prst="rect">
             <a:avLst/>
@@ -4050,43 +3939,7 @@
               <a:buNone/>
             </a:pPr>
             <a:r>
-              <a:rPr lang="en-US" sz="6000" dirty="0">
-                <a:solidFill>
-                  <a:srgbClr val="000000"/>
-                </a:solidFill>
-              </a:rPr>
-              <a:t>👨‍👩‍👧‍👦</a:t>
-            </a:r>
-            <a:endParaRPr lang="en-US" sz="6000" dirty="0"/>
-          </a:p>
-        </p:txBody>
-      </p:sp>
-      <p:sp>
-        <p:nvSpPr>
-          <p:cNvPr id="7" name="Text 5"/>
-          <p:cNvSpPr/>
-          <p:nvPr/>
-        </p:nvSpPr>
-        <p:spPr>
-          <a:xfrm>
-            <a:off x="685800" y="3639312"/>
-            <a:ext cx="1938528" cy="548640"/>
-          </a:xfrm>
-          <a:prstGeom prst="rect">
-            <a:avLst/>
-          </a:prstGeom>
-          <a:noFill/>
-          <a:ln/>
-        </p:spPr>
-        <p:txBody>
-          <a:bodyPr wrap="square" lIns="0" tIns="0" rIns="0" bIns="0" rtlCol="0" anchor="ctr"/>
-          <a:lstStyle/>
-          <a:p>
-            <a:pPr algn="ctr" indent="0" marL="0">
-              <a:buNone/>
-            </a:pPr>
-            <a:r>
-              <a:rPr lang="en-US" sz="1400" b="1" dirty="0">
+              <a:rPr lang="en-US" sz="1300" b="1" spc="200" kern="0" dirty="0">
                 <a:solidFill>
                   <a:srgbClr val="2B1B14"/>
                 </a:solidFill>
@@ -4096,24 +3949,24 @@
               </a:rPr>
               <a:t>Family meals</a:t>
             </a:r>
-            <a:endParaRPr lang="en-US" sz="1400" dirty="0"/>
-          </a:p>
-        </p:txBody>
-      </p:sp>
-      <p:sp>
-        <p:nvSpPr>
-          <p:cNvPr id="8" name="Shape 6"/>
+            <a:endParaRPr lang="en-US" sz="1300" dirty="0"/>
+          </a:p>
+        </p:txBody>
+      </p:sp>
+      <p:sp>
+        <p:nvSpPr>
+          <p:cNvPr id="9" name="Shape 5"/>
           <p:cNvSpPr/>
           <p:nvPr/>
         </p:nvSpPr>
         <p:spPr>
           <a:xfrm>
             <a:off x="2916936" y="2148840"/>
-            <a:ext cx="1938528" cy="2148840"/>
+            <a:ext cx="1938528" cy="2194560"/>
           </a:xfrm>
           <a:prstGeom prst="roundRect">
             <a:avLst>
-              <a:gd name="adj" fmla="val 9434"/>
+              <a:gd name="adj" fmla="val 7547"/>
             </a:avLst>
           </a:prstGeom>
           <a:solidFill>
@@ -4122,23 +3975,46 @@
           <a:ln/>
           <a:effectLst>
             <a:outerShdw sx="100000" sy="100000" kx="0" ky="0" algn="bl" rotWithShape="0" blurRad="177800" dist="76200" dir="5400000">
-              <a:srgbClr val="3d1810">
+              <a:srgbClr val="1C1109">
                 <a:alpha val="50000"/>
               </a:srgbClr>
             </a:outerShdw>
           </a:effectLst>
         </p:spPr>
       </p:sp>
-      <p:sp>
-        <p:nvSpPr>
-          <p:cNvPr id="9" name="Text 7"/>
-          <p:cNvSpPr/>
-          <p:nvPr/>
-        </p:nvSpPr>
-        <p:spPr>
-          <a:xfrm>
-            <a:off x="2916936" y="2286000"/>
-            <a:ext cx="1938528" cy="1234440"/>
+      <p:pic>
+        <p:nvPicPr>
+          <p:cNvPr id="10" name="Image 1" descr="/home/user/Wristworkswebsite/presentation/art_cookie.png">    </p:cNvPr>
+          <p:cNvPicPr>
+            <a:picLocks noChangeAspect="1"/>
+          </p:cNvPicPr>
+          <p:nvPr/>
+        </p:nvPicPr>
+        <p:blipFill>
+          <a:blip r:embed="rId3"/>
+          <a:srcRect l="0" r="0" t="0" b="0"/>
+          <a:stretch/>
+        </p:blipFill>
+        <p:spPr>
+          <a:xfrm>
+            <a:off x="3044952" y="2276856"/>
+            <a:ext cx="1682496" cy="1645920"/>
+          </a:xfrm>
+          <a:prstGeom prst="rect">
+            <a:avLst/>
+          </a:prstGeom>
+        </p:spPr>
+      </p:pic>
+      <p:sp>
+        <p:nvSpPr>
+          <p:cNvPr id="11" name="Text 6"/>
+          <p:cNvSpPr/>
+          <p:nvPr/>
+        </p:nvSpPr>
+        <p:spPr>
+          <a:xfrm>
+            <a:off x="2916936" y="3959352"/>
+            <a:ext cx="1938528" cy="329184"/>
           </a:xfrm>
           <a:prstGeom prst="rect">
             <a:avLst/>
@@ -4154,43 +4030,7 @@
               <a:buNone/>
             </a:pPr>
             <a:r>
-              <a:rPr lang="en-US" sz="6000" dirty="0">
-                <a:solidFill>
-                  <a:srgbClr val="000000"/>
-                </a:solidFill>
-              </a:rPr>
-              <a:t>🍪</a:t>
-            </a:r>
-            <a:endParaRPr lang="en-US" sz="6000" dirty="0"/>
-          </a:p>
-        </p:txBody>
-      </p:sp>
-      <p:sp>
-        <p:nvSpPr>
-          <p:cNvPr id="10" name="Text 8"/>
-          <p:cNvSpPr/>
-          <p:nvPr/>
-        </p:nvSpPr>
-        <p:spPr>
-          <a:xfrm>
-            <a:off x="2916936" y="3639312"/>
-            <a:ext cx="1938528" cy="548640"/>
-          </a:xfrm>
-          <a:prstGeom prst="rect">
-            <a:avLst/>
-          </a:prstGeom>
-          <a:noFill/>
-          <a:ln/>
-        </p:spPr>
-        <p:txBody>
-          <a:bodyPr wrap="square" lIns="0" tIns="0" rIns="0" bIns="0" rtlCol="0" anchor="ctr"/>
-          <a:lstStyle/>
-          <a:p>
-            <a:pPr algn="ctr" indent="0" marL="0">
-              <a:buNone/>
-            </a:pPr>
-            <a:r>
-              <a:rPr lang="en-US" sz="1400" b="1" dirty="0">
+              <a:rPr lang="en-US" sz="1300" b="1" spc="200" kern="0" dirty="0">
                 <a:solidFill>
                   <a:srgbClr val="2B1B14"/>
                 </a:solidFill>
@@ -4200,24 +4040,24 @@
               </a:rPr>
               <a:t>Childhood treats</a:t>
             </a:r>
-            <a:endParaRPr lang="en-US" sz="1400" dirty="0"/>
-          </a:p>
-        </p:txBody>
-      </p:sp>
-      <p:sp>
-        <p:nvSpPr>
-          <p:cNvPr id="11" name="Shape 9"/>
+            <a:endParaRPr lang="en-US" sz="1300" dirty="0"/>
+          </a:p>
+        </p:txBody>
+      </p:sp>
+      <p:sp>
+        <p:nvSpPr>
+          <p:cNvPr id="12" name="Shape 7"/>
           <p:cNvSpPr/>
           <p:nvPr/>
         </p:nvSpPr>
         <p:spPr>
           <a:xfrm>
             <a:off x="5148072" y="2148840"/>
-            <a:ext cx="1938528" cy="2148840"/>
+            <a:ext cx="1938528" cy="2194560"/>
           </a:xfrm>
           <a:prstGeom prst="roundRect">
             <a:avLst>
-              <a:gd name="adj" fmla="val 9434"/>
+              <a:gd name="adj" fmla="val 7547"/>
             </a:avLst>
           </a:prstGeom>
           <a:solidFill>
@@ -4226,23 +4066,46 @@
           <a:ln/>
           <a:effectLst>
             <a:outerShdw sx="100000" sy="100000" kx="0" ky="0" algn="bl" rotWithShape="0" blurRad="177800" dist="76200" dir="5400000">
-              <a:srgbClr val="3d1810">
+              <a:srgbClr val="1C1109">
                 <a:alpha val="50000"/>
               </a:srgbClr>
             </a:outerShdw>
           </a:effectLst>
         </p:spPr>
       </p:sp>
-      <p:sp>
-        <p:nvSpPr>
-          <p:cNvPr id="12" name="Text 10"/>
-          <p:cNvSpPr/>
-          <p:nvPr/>
-        </p:nvSpPr>
-        <p:spPr>
-          <a:xfrm>
-            <a:off x="5148072" y="2286000"/>
-            <a:ext cx="1938528" cy="1234440"/>
+      <p:pic>
+        <p:nvPicPr>
+          <p:cNvPr id="13" name="Image 2" descr="/home/user/Wristworkswebsite/presentation/art_bday.png">    </p:cNvPr>
+          <p:cNvPicPr>
+            <a:picLocks noChangeAspect="1"/>
+          </p:cNvPicPr>
+          <p:nvPr/>
+        </p:nvPicPr>
+        <p:blipFill>
+          <a:blip r:embed="rId4"/>
+          <a:srcRect l="0" r="0" t="0" b="0"/>
+          <a:stretch/>
+        </p:blipFill>
+        <p:spPr>
+          <a:xfrm>
+            <a:off x="5276088" y="2276856"/>
+            <a:ext cx="1682496" cy="1645920"/>
+          </a:xfrm>
+          <a:prstGeom prst="rect">
+            <a:avLst/>
+          </a:prstGeom>
+        </p:spPr>
+      </p:pic>
+      <p:sp>
+        <p:nvSpPr>
+          <p:cNvPr id="14" name="Text 8"/>
+          <p:cNvSpPr/>
+          <p:nvPr/>
+        </p:nvSpPr>
+        <p:spPr>
+          <a:xfrm>
+            <a:off x="5148072" y="3959352"/>
+            <a:ext cx="1938528" cy="329184"/>
           </a:xfrm>
           <a:prstGeom prst="rect">
             <a:avLst/>
@@ -4258,43 +4121,7 @@
               <a:buNone/>
             </a:pPr>
             <a:r>
-              <a:rPr lang="en-US" sz="6000" dirty="0">
-                <a:solidFill>
-                  <a:srgbClr val="000000"/>
-                </a:solidFill>
-              </a:rPr>
-              <a:t>🎂</a:t>
-            </a:r>
-            <a:endParaRPr lang="en-US" sz="6000" dirty="0"/>
-          </a:p>
-        </p:txBody>
-      </p:sp>
-      <p:sp>
-        <p:nvSpPr>
-          <p:cNvPr id="13" name="Text 11"/>
-          <p:cNvSpPr/>
-          <p:nvPr/>
-        </p:nvSpPr>
-        <p:spPr>
-          <a:xfrm>
-            <a:off x="5148072" y="3639312"/>
-            <a:ext cx="1938528" cy="548640"/>
-          </a:xfrm>
-          <a:prstGeom prst="rect">
-            <a:avLst/>
-          </a:prstGeom>
-          <a:noFill/>
-          <a:ln/>
-        </p:spPr>
-        <p:txBody>
-          <a:bodyPr wrap="square" lIns="0" tIns="0" rIns="0" bIns="0" rtlCol="0" anchor="ctr"/>
-          <a:lstStyle/>
-          <a:p>
-            <a:pPr algn="ctr" indent="0" marL="0">
-              <a:buNone/>
-            </a:pPr>
-            <a:r>
-              <a:rPr lang="en-US" sz="1400" b="1" dirty="0">
+              <a:rPr lang="en-US" sz="1300" b="1" spc="200" kern="0" dirty="0">
                 <a:solidFill>
                   <a:srgbClr val="2B1B14"/>
                 </a:solidFill>
@@ -4304,24 +4131,24 @@
               </a:rPr>
               <a:t>Celebrations</a:t>
             </a:r>
-            <a:endParaRPr lang="en-US" sz="1400" dirty="0"/>
-          </a:p>
-        </p:txBody>
-      </p:sp>
-      <p:sp>
-        <p:nvSpPr>
-          <p:cNvPr id="14" name="Shape 12"/>
+            <a:endParaRPr lang="en-US" sz="1300" dirty="0"/>
+          </a:p>
+        </p:txBody>
+      </p:sp>
+      <p:sp>
+        <p:nvSpPr>
+          <p:cNvPr id="15" name="Shape 9"/>
           <p:cNvSpPr/>
           <p:nvPr/>
         </p:nvSpPr>
         <p:spPr>
           <a:xfrm>
             <a:off x="7379208" y="2148840"/>
-            <a:ext cx="1938528" cy="2148840"/>
+            <a:ext cx="1938528" cy="2194560"/>
           </a:xfrm>
           <a:prstGeom prst="roundRect">
             <a:avLst>
-              <a:gd name="adj" fmla="val 9434"/>
+              <a:gd name="adj" fmla="val 7547"/>
             </a:avLst>
           </a:prstGeom>
           <a:solidFill>
@@ -4330,23 +4157,46 @@
           <a:ln/>
           <a:effectLst>
             <a:outerShdw sx="100000" sy="100000" kx="0" ky="0" algn="bl" rotWithShape="0" blurRad="177800" dist="76200" dir="5400000">
-              <a:srgbClr val="3d1810">
+              <a:srgbClr val="1C1109">
                 <a:alpha val="50000"/>
               </a:srgbClr>
             </a:outerShdw>
           </a:effectLst>
         </p:spPr>
       </p:sp>
-      <p:sp>
-        <p:nvSpPr>
-          <p:cNvPr id="15" name="Text 13"/>
-          <p:cNvSpPr/>
-          <p:nvPr/>
-        </p:nvSpPr>
-        <p:spPr>
-          <a:xfrm>
-            <a:off x="7379208" y="2286000"/>
-            <a:ext cx="1938528" cy="1234440"/>
+      <p:pic>
+        <p:nvPicPr>
+          <p:cNvPr id="16" name="Image 3" descr="/home/user/Wristworkswebsite/presentation/art_pot.png">    </p:cNvPr>
+          <p:cNvPicPr>
+            <a:picLocks noChangeAspect="1"/>
+          </p:cNvPicPr>
+          <p:nvPr/>
+        </p:nvPicPr>
+        <p:blipFill>
+          <a:blip r:embed="rId5"/>
+          <a:srcRect l="0" r="0" t="0" b="0"/>
+          <a:stretch/>
+        </p:blipFill>
+        <p:spPr>
+          <a:xfrm>
+            <a:off x="7507224" y="2276856"/>
+            <a:ext cx="1682496" cy="1645920"/>
+          </a:xfrm>
+          <a:prstGeom prst="rect">
+            <a:avLst/>
+          </a:prstGeom>
+        </p:spPr>
+      </p:pic>
+      <p:sp>
+        <p:nvSpPr>
+          <p:cNvPr id="17" name="Text 10"/>
+          <p:cNvSpPr/>
+          <p:nvPr/>
+        </p:nvSpPr>
+        <p:spPr>
+          <a:xfrm>
+            <a:off x="7379208" y="3959352"/>
+            <a:ext cx="1938528" cy="329184"/>
           </a:xfrm>
           <a:prstGeom prst="rect">
             <a:avLst/>
@@ -4362,43 +4212,7 @@
               <a:buNone/>
             </a:pPr>
             <a:r>
-              <a:rPr lang="en-US" sz="6000" dirty="0">
-                <a:solidFill>
-                  <a:srgbClr val="000000"/>
-                </a:solidFill>
-              </a:rPr>
-              <a:t>🍲</a:t>
-            </a:r>
-            <a:endParaRPr lang="en-US" sz="6000" dirty="0"/>
-          </a:p>
-        </p:txBody>
-      </p:sp>
-      <p:sp>
-        <p:nvSpPr>
-          <p:cNvPr id="16" name="Text 14"/>
-          <p:cNvSpPr/>
-          <p:nvPr/>
-        </p:nvSpPr>
-        <p:spPr>
-          <a:xfrm>
-            <a:off x="7379208" y="3639312"/>
-            <a:ext cx="1938528" cy="548640"/>
-          </a:xfrm>
-          <a:prstGeom prst="rect">
-            <a:avLst/>
-          </a:prstGeom>
-          <a:noFill/>
-          <a:ln/>
-        </p:spPr>
-        <p:txBody>
-          <a:bodyPr wrap="square" lIns="0" tIns="0" rIns="0" bIns="0" rtlCol="0" anchor="ctr"/>
-          <a:lstStyle/>
-          <a:p>
-            <a:pPr algn="ctr" indent="0" marL="0">
-              <a:buNone/>
-            </a:pPr>
-            <a:r>
-              <a:rPr lang="en-US" sz="1400" b="1" dirty="0">
+              <a:rPr lang="en-US" sz="1300" b="1" spc="200" kern="0" dirty="0">
                 <a:solidFill>
                   <a:srgbClr val="2B1B14"/>
                 </a:solidFill>
@@ -4408,24 +4222,24 @@
               </a:rPr>
               <a:t>Home cooking</a:t>
             </a:r>
-            <a:endParaRPr lang="en-US" sz="1400" dirty="0"/>
-          </a:p>
-        </p:txBody>
-      </p:sp>
-      <p:sp>
-        <p:nvSpPr>
-          <p:cNvPr id="17" name="Shape 15"/>
+            <a:endParaRPr lang="en-US" sz="1300" dirty="0"/>
+          </a:p>
+        </p:txBody>
+      </p:sp>
+      <p:sp>
+        <p:nvSpPr>
+          <p:cNvPr id="18" name="Shape 11"/>
           <p:cNvSpPr/>
           <p:nvPr/>
         </p:nvSpPr>
         <p:spPr>
           <a:xfrm>
             <a:off x="9610344" y="2148840"/>
-            <a:ext cx="1938528" cy="2148840"/>
+            <a:ext cx="1938528" cy="2194560"/>
           </a:xfrm>
           <a:prstGeom prst="roundRect">
             <a:avLst>
-              <a:gd name="adj" fmla="val 9434"/>
+              <a:gd name="adj" fmla="val 7547"/>
             </a:avLst>
           </a:prstGeom>
           <a:solidFill>
@@ -4434,23 +4248,46 @@
           <a:ln/>
           <a:effectLst>
             <a:outerShdw sx="100000" sy="100000" kx="0" ky="0" algn="bl" rotWithShape="0" blurRad="177800" dist="76200" dir="5400000">
-              <a:srgbClr val="3d1810">
+              <a:srgbClr val="1C1109">
                 <a:alpha val="50000"/>
               </a:srgbClr>
             </a:outerShdw>
           </a:effectLst>
         </p:spPr>
       </p:sp>
-      <p:sp>
-        <p:nvSpPr>
-          <p:cNvPr id="18" name="Text 16"/>
-          <p:cNvSpPr/>
-          <p:nvPr/>
-        </p:nvSpPr>
-        <p:spPr>
-          <a:xfrm>
-            <a:off x="9610344" y="2286000"/>
-            <a:ext cx="1938528" cy="1234440"/>
+      <p:pic>
+        <p:nvPicPr>
+          <p:cNvPr id="19" name="Image 4" descr="/home/user/Wristworkswebsite/presentation/art_coffee.png">    </p:cNvPr>
+          <p:cNvPicPr>
+            <a:picLocks noChangeAspect="1"/>
+          </p:cNvPicPr>
+          <p:nvPr/>
+        </p:nvPicPr>
+        <p:blipFill>
+          <a:blip r:embed="rId6"/>
+          <a:srcRect l="0" r="0" t="0" b="0"/>
+          <a:stretch/>
+        </p:blipFill>
+        <p:spPr>
+          <a:xfrm>
+            <a:off x="9738360" y="2276856"/>
+            <a:ext cx="1682496" cy="1645920"/>
+          </a:xfrm>
+          <a:prstGeom prst="rect">
+            <a:avLst/>
+          </a:prstGeom>
+        </p:spPr>
+      </p:pic>
+      <p:sp>
+        <p:nvSpPr>
+          <p:cNvPr id="20" name="Text 12"/>
+          <p:cNvSpPr/>
+          <p:nvPr/>
+        </p:nvSpPr>
+        <p:spPr>
+          <a:xfrm>
+            <a:off x="9610344" y="3959352"/>
+            <a:ext cx="1938528" cy="329184"/>
           </a:xfrm>
           <a:prstGeom prst="rect">
             <a:avLst/>
@@ -4466,43 +4303,7 @@
               <a:buNone/>
             </a:pPr>
             <a:r>
-              <a:rPr lang="en-US" sz="6000" dirty="0">
-                <a:solidFill>
-                  <a:srgbClr val="000000"/>
-                </a:solidFill>
-              </a:rPr>
-              <a:t>☕</a:t>
-            </a:r>
-            <a:endParaRPr lang="en-US" sz="6000" dirty="0"/>
-          </a:p>
-        </p:txBody>
-      </p:sp>
-      <p:sp>
-        <p:nvSpPr>
-          <p:cNvPr id="19" name="Text 17"/>
-          <p:cNvSpPr/>
-          <p:nvPr/>
-        </p:nvSpPr>
-        <p:spPr>
-          <a:xfrm>
-            <a:off x="9610344" y="3639312"/>
-            <a:ext cx="1938528" cy="548640"/>
-          </a:xfrm>
-          <a:prstGeom prst="rect">
-            <a:avLst/>
-          </a:prstGeom>
-          <a:noFill/>
-          <a:ln/>
-        </p:spPr>
-        <p:txBody>
-          <a:bodyPr wrap="square" lIns="0" tIns="0" rIns="0" bIns="0" rtlCol="0" anchor="ctr"/>
-          <a:lstStyle/>
-          <a:p>
-            <a:pPr algn="ctr" indent="0" marL="0">
-              <a:buNone/>
-            </a:pPr>
-            <a:r>
-              <a:rPr lang="en-US" sz="1400" b="1" dirty="0">
+              <a:rPr lang="en-US" sz="1300" b="1" spc="200" kern="0" dirty="0">
                 <a:solidFill>
                   <a:srgbClr val="2B1B14"/>
                 </a:solidFill>
@@ -4512,19 +4313,19 @@
               </a:rPr>
               <a:t>Comfort in a cup</a:t>
             </a:r>
-            <a:endParaRPr lang="en-US" sz="1400" dirty="0"/>
-          </a:p>
-        </p:txBody>
-      </p:sp>
-      <p:sp>
-        <p:nvSpPr>
-          <p:cNvPr id="20" name="Text 18"/>
-          <p:cNvSpPr/>
-          <p:nvPr/>
-        </p:nvSpPr>
-        <p:spPr>
-          <a:xfrm>
-            <a:off x="658368" y="4709160"/>
+            <a:endParaRPr lang="en-US" sz="1300" dirty="0"/>
+          </a:p>
+        </p:txBody>
+      </p:sp>
+      <p:sp>
+        <p:nvSpPr>
+          <p:cNvPr id="21" name="Text 13"/>
+          <p:cNvSpPr/>
+          <p:nvPr/>
+        </p:nvSpPr>
+        <p:spPr>
+          <a:xfrm>
+            <a:off x="658368" y="4754880"/>
             <a:ext cx="10972800" cy="731520"/>
           </a:xfrm>
           <a:prstGeom prst="rect">
@@ -4557,13 +4358,13 @@
       </p:sp>
       <p:sp>
         <p:nvSpPr>
-          <p:cNvPr id="21" name="Text 19"/>
-          <p:cNvSpPr/>
-          <p:nvPr/>
-        </p:nvSpPr>
-        <p:spPr>
-          <a:xfrm>
-            <a:off x="685800" y="5532120"/>
+          <p:cNvPr id="22" name="Text 14"/>
+          <p:cNvSpPr/>
+          <p:nvPr/>
+        </p:nvSpPr>
+        <p:spPr>
+          <a:xfrm>
+            <a:off x="685800" y="5559552"/>
             <a:ext cx="10515600" cy="548640"/>
           </a:xfrm>
           <a:prstGeom prst="rect">
@@ -4635,7 +4436,7 @@
       </p:grpSpPr>
       <p:sp>
         <p:nvSpPr>
-          <p:cNvPr id="2" name="Shape 0"/>
+          <p:cNvPr id="3" name="Shape 0"/>
           <p:cNvSpPr/>
           <p:nvPr/>
         </p:nvSpPr>
@@ -4657,7 +4458,7 @@
       </p:sp>
       <p:sp>
         <p:nvSpPr>
-          <p:cNvPr id="3" name="Text 1"/>
+          <p:cNvPr id="4" name="Text 1"/>
           <p:cNvSpPr/>
           <p:nvPr/>
         </p:nvSpPr>
@@ -4696,7 +4497,7 @@
       </p:sp>
       <p:sp>
         <p:nvSpPr>
-          <p:cNvPr id="4" name="Text 2"/>
+          <p:cNvPr id="5" name="Text 2"/>
           <p:cNvSpPr/>
           <p:nvPr/>
         </p:nvSpPr>
@@ -4735,14 +4536,14 @@
       </p:sp>
       <p:sp>
         <p:nvSpPr>
-          <p:cNvPr id="5" name="Shape 3"/>
+          <p:cNvPr id="6" name="Shape 3"/>
           <p:cNvSpPr/>
           <p:nvPr/>
         </p:nvSpPr>
         <p:spPr>
           <a:xfrm>
             <a:off x="777240" y="2011680"/>
-            <a:ext cx="4572000" cy="658368"/>
+            <a:ext cx="4754880" cy="658368"/>
           </a:xfrm>
           <a:prstGeom prst="roundRect">
             <a:avLst>
@@ -4762,16 +4563,78 @@
           </a:effectLst>
         </p:spPr>
       </p:sp>
-      <p:sp>
-        <p:nvSpPr>
-          <p:cNvPr id="6" name="Text 4"/>
-          <p:cNvSpPr/>
-          <p:nvPr/>
-        </p:nvSpPr>
-        <p:spPr>
-          <a:xfrm>
-            <a:off x="905256" y="2011680"/>
-            <a:ext cx="685800" cy="658368"/>
+      <p:pic>
+        <p:nvPicPr>
+          <p:cNvPr id="7" name="Image 0" descr="/home/user/Wristworkswebsite/presentation/icon_eye_l.png">    </p:cNvPr>
+          <p:cNvPicPr>
+            <a:picLocks noChangeAspect="1"/>
+          </p:cNvPicPr>
+          <p:nvPr/>
+        </p:nvPicPr>
+        <p:blipFill>
+          <a:blip r:embed="rId2"/>
+          <a:srcRect l="0" r="0" t="0" b="0"/>
+          <a:stretch/>
+        </p:blipFill>
+        <p:spPr>
+          <a:xfrm>
+            <a:off x="923544" y="2130552"/>
+            <a:ext cx="457200" cy="420624"/>
+          </a:xfrm>
+          <a:prstGeom prst="rect">
+            <a:avLst/>
+          </a:prstGeom>
+        </p:spPr>
+      </p:pic>
+      <p:sp>
+        <p:nvSpPr>
+          <p:cNvPr id="8" name="Text 4"/>
+          <p:cNvSpPr/>
+          <p:nvPr/>
+        </p:nvSpPr>
+        <p:spPr>
+          <a:xfrm>
+            <a:off x="1527048" y="2011680"/>
+            <a:ext cx="3840480" cy="658368"/>
+          </a:xfrm>
+          <a:prstGeom prst="rect">
+            <a:avLst/>
+          </a:prstGeom>
+          <a:noFill/>
+          <a:ln/>
+        </p:spPr>
+        <p:txBody>
+          <a:bodyPr wrap="square" lIns="0" tIns="0" rIns="0" bIns="0" rtlCol="0" anchor="ctr"/>
+          <a:lstStyle/>
+          <a:p>
+            <a:pPr algn="l" indent="0" marL="0">
+              <a:buNone/>
+            </a:pPr>
+            <a:r>
+              <a:rPr lang="en-US" sz="1800" b="1" dirty="0">
+                <a:solidFill>
+                  <a:srgbClr val="FDF6EC"/>
+                </a:solidFill>
+                <a:latin typeface="Montserrat" pitchFamily="34" charset="0"/>
+                <a:ea typeface="Montserrat" pitchFamily="34" charset="-122"/>
+                <a:cs typeface="Montserrat" pitchFamily="34" charset="-120"/>
+              </a:rPr>
+              <a:t>WHAT WE SEE</a:t>
+            </a:r>
+            <a:endParaRPr lang="en-US" sz="1800" dirty="0"/>
+          </a:p>
+        </p:txBody>
+      </p:sp>
+      <p:sp>
+        <p:nvSpPr>
+          <p:cNvPr id="9" name="Text 5"/>
+          <p:cNvSpPr/>
+          <p:nvPr/>
+        </p:nvSpPr>
+        <p:spPr>
+          <a:xfrm>
+            <a:off x="777240" y="2596896"/>
+            <a:ext cx="4754880" cy="320040"/>
           </a:xfrm>
           <a:prstGeom prst="rect">
             <a:avLst/>
@@ -4787,51 +4650,15 @@
               <a:buNone/>
             </a:pPr>
             <a:r>
-              <a:rPr lang="en-US" sz="2600" dirty="0">
-                <a:solidFill>
-                  <a:srgbClr val="000000"/>
-                </a:solidFill>
-              </a:rPr>
-              <a:t>👀</a:t>
-            </a:r>
-            <a:endParaRPr lang="en-US" sz="2600" dirty="0"/>
-          </a:p>
-        </p:txBody>
-      </p:sp>
-      <p:sp>
-        <p:nvSpPr>
-          <p:cNvPr id="7" name="Text 5"/>
-          <p:cNvSpPr/>
-          <p:nvPr/>
-        </p:nvSpPr>
-        <p:spPr>
-          <a:xfrm>
-            <a:off x="1645920" y="2011680"/>
-            <a:ext cx="3566160" cy="658368"/>
-          </a:xfrm>
-          <a:prstGeom prst="rect">
-            <a:avLst/>
-          </a:prstGeom>
-          <a:noFill/>
-          <a:ln/>
-        </p:spPr>
-        <p:txBody>
-          <a:bodyPr wrap="square" lIns="0" tIns="0" rIns="0" bIns="0" rtlCol="0" anchor="ctr"/>
-          <a:lstStyle/>
-          <a:p>
-            <a:pPr algn="l" indent="0" marL="0">
-              <a:buNone/>
-            </a:pPr>
-            <a:r>
               <a:rPr lang="en-US" sz="1800" b="1" dirty="0">
                 <a:solidFill>
-                  <a:srgbClr val="FDF6EC"/>
-                </a:solidFill>
-                <a:latin typeface="Montserrat" pitchFamily="34" charset="0"/>
-                <a:ea typeface="Montserrat" pitchFamily="34" charset="-122"/>
-                <a:cs typeface="Montserrat" pitchFamily="34" charset="-120"/>
-              </a:rPr>
-              <a:t>WHAT WE SEE</a:t>
+                  <a:srgbClr val="E8722C"/>
+                </a:solidFill>
+                <a:latin typeface="Montserrat" pitchFamily="34" charset="0"/>
+                <a:ea typeface="Montserrat" pitchFamily="34" charset="-122"/>
+                <a:cs typeface="Montserrat" pitchFamily="34" charset="-120"/>
+              </a:rPr>
+              <a:t>↓</a:t>
             </a:r>
             <a:endParaRPr lang="en-US" sz="1800" dirty="0"/>
           </a:p>
@@ -4839,53 +4666,14 @@
       </p:sp>
       <p:sp>
         <p:nvSpPr>
-          <p:cNvPr id="8" name="Text 6"/>
-          <p:cNvSpPr/>
-          <p:nvPr/>
-        </p:nvSpPr>
-        <p:spPr>
-          <a:xfrm>
-            <a:off x="777240" y="2596896"/>
-            <a:ext cx="4572000" cy="320040"/>
-          </a:xfrm>
-          <a:prstGeom prst="rect">
-            <a:avLst/>
-          </a:prstGeom>
-          <a:noFill/>
-          <a:ln/>
-        </p:spPr>
-        <p:txBody>
-          <a:bodyPr wrap="square" lIns="0" tIns="0" rIns="0" bIns="0" rtlCol="0" anchor="ctr"/>
-          <a:lstStyle/>
-          <a:p>
-            <a:pPr algn="ctr" indent="0" marL="0">
-              <a:buNone/>
-            </a:pPr>
-            <a:r>
-              <a:rPr lang="en-US" sz="1800" b="1" dirty="0">
-                <a:solidFill>
-                  <a:srgbClr val="E8722C"/>
-                </a:solidFill>
-                <a:latin typeface="Montserrat" pitchFamily="34" charset="0"/>
-                <a:ea typeface="Montserrat" pitchFamily="34" charset="-122"/>
-                <a:cs typeface="Montserrat" pitchFamily="34" charset="-120"/>
-              </a:rPr>
-              <a:t>↓</a:t>
-            </a:r>
-            <a:endParaRPr lang="en-US" sz="1800" dirty="0"/>
-          </a:p>
-        </p:txBody>
-      </p:sp>
-      <p:sp>
-        <p:nvSpPr>
-          <p:cNvPr id="9" name="Shape 7"/>
+          <p:cNvPr id="10" name="Shape 6"/>
           <p:cNvSpPr/>
           <p:nvPr/>
         </p:nvSpPr>
         <p:spPr>
           <a:xfrm>
             <a:off x="777240" y="2834640"/>
-            <a:ext cx="4572000" cy="658368"/>
+            <a:ext cx="4754880" cy="658368"/>
           </a:xfrm>
           <a:prstGeom prst="roundRect">
             <a:avLst>
@@ -4905,16 +4693,78 @@
           </a:effectLst>
         </p:spPr>
       </p:sp>
-      <p:sp>
-        <p:nvSpPr>
-          <p:cNvPr id="10" name="Text 8"/>
-          <p:cNvSpPr/>
-          <p:nvPr/>
-        </p:nvSpPr>
-        <p:spPr>
-          <a:xfrm>
-            <a:off x="905256" y="2834640"/>
-            <a:ext cx="685800" cy="658368"/>
+      <p:pic>
+        <p:nvPicPr>
+          <p:cNvPr id="11" name="Image 1" descr="/home/user/Wristworkswebsite/presentation/icon_brain_l.png">    </p:cNvPr>
+          <p:cNvPicPr>
+            <a:picLocks noChangeAspect="1"/>
+          </p:cNvPicPr>
+          <p:nvPr/>
+        </p:nvPicPr>
+        <p:blipFill>
+          <a:blip r:embed="rId3"/>
+          <a:srcRect l="0" r="0" t="0" b="0"/>
+          <a:stretch/>
+        </p:blipFill>
+        <p:spPr>
+          <a:xfrm>
+            <a:off x="923544" y="2953512"/>
+            <a:ext cx="457200" cy="420624"/>
+          </a:xfrm>
+          <a:prstGeom prst="rect">
+            <a:avLst/>
+          </a:prstGeom>
+        </p:spPr>
+      </p:pic>
+      <p:sp>
+        <p:nvSpPr>
+          <p:cNvPr id="12" name="Text 7"/>
+          <p:cNvSpPr/>
+          <p:nvPr/>
+        </p:nvSpPr>
+        <p:spPr>
+          <a:xfrm>
+            <a:off x="1527048" y="2834640"/>
+            <a:ext cx="3840480" cy="658368"/>
+          </a:xfrm>
+          <a:prstGeom prst="rect">
+            <a:avLst/>
+          </a:prstGeom>
+          <a:noFill/>
+          <a:ln/>
+        </p:spPr>
+        <p:txBody>
+          <a:bodyPr wrap="square" lIns="0" tIns="0" rIns="0" bIns="0" rtlCol="0" anchor="ctr"/>
+          <a:lstStyle/>
+          <a:p>
+            <a:pPr algn="l" indent="0" marL="0">
+              <a:buNone/>
+            </a:pPr>
+            <a:r>
+              <a:rPr lang="en-US" sz="1800" b="1" dirty="0">
+                <a:solidFill>
+                  <a:srgbClr val="FDF6EC"/>
+                </a:solidFill>
+                <a:latin typeface="Montserrat" pitchFamily="34" charset="0"/>
+                <a:ea typeface="Montserrat" pitchFamily="34" charset="-122"/>
+                <a:cs typeface="Montserrat" pitchFamily="34" charset="-120"/>
+              </a:rPr>
+              <a:t>WHAT WE EXPECT</a:t>
+            </a:r>
+            <a:endParaRPr lang="en-US" sz="1800" dirty="0"/>
+          </a:p>
+        </p:txBody>
+      </p:sp>
+      <p:sp>
+        <p:nvSpPr>
+          <p:cNvPr id="13" name="Text 8"/>
+          <p:cNvSpPr/>
+          <p:nvPr/>
+        </p:nvSpPr>
+        <p:spPr>
+          <a:xfrm>
+            <a:off x="777240" y="3419856"/>
+            <a:ext cx="4754880" cy="320040"/>
           </a:xfrm>
           <a:prstGeom prst="rect">
             <a:avLst/>
@@ -4930,51 +4780,15 @@
               <a:buNone/>
             </a:pPr>
             <a:r>
-              <a:rPr lang="en-US" sz="2600" dirty="0">
-                <a:solidFill>
-                  <a:srgbClr val="000000"/>
-                </a:solidFill>
-              </a:rPr>
-              <a:t>🧠</a:t>
-            </a:r>
-            <a:endParaRPr lang="en-US" sz="2600" dirty="0"/>
-          </a:p>
-        </p:txBody>
-      </p:sp>
-      <p:sp>
-        <p:nvSpPr>
-          <p:cNvPr id="11" name="Text 9"/>
-          <p:cNvSpPr/>
-          <p:nvPr/>
-        </p:nvSpPr>
-        <p:spPr>
-          <a:xfrm>
-            <a:off x="1645920" y="2834640"/>
-            <a:ext cx="3566160" cy="658368"/>
-          </a:xfrm>
-          <a:prstGeom prst="rect">
-            <a:avLst/>
-          </a:prstGeom>
-          <a:noFill/>
-          <a:ln/>
-        </p:spPr>
-        <p:txBody>
-          <a:bodyPr wrap="square" lIns="0" tIns="0" rIns="0" bIns="0" rtlCol="0" anchor="ctr"/>
-          <a:lstStyle/>
-          <a:p>
-            <a:pPr algn="l" indent="0" marL="0">
-              <a:buNone/>
-            </a:pPr>
-            <a:r>
               <a:rPr lang="en-US" sz="1800" b="1" dirty="0">
                 <a:solidFill>
-                  <a:srgbClr val="FDF6EC"/>
-                </a:solidFill>
-                <a:latin typeface="Montserrat" pitchFamily="34" charset="0"/>
-                <a:ea typeface="Montserrat" pitchFamily="34" charset="-122"/>
-                <a:cs typeface="Montserrat" pitchFamily="34" charset="-120"/>
-              </a:rPr>
-              <a:t>WHAT WE EXPECT</a:t>
+                  <a:srgbClr val="E8722C"/>
+                </a:solidFill>
+                <a:latin typeface="Montserrat" pitchFamily="34" charset="0"/>
+                <a:ea typeface="Montserrat" pitchFamily="34" charset="-122"/>
+                <a:cs typeface="Montserrat" pitchFamily="34" charset="-120"/>
+              </a:rPr>
+              <a:t>↓</a:t>
             </a:r>
             <a:endParaRPr lang="en-US" sz="1800" dirty="0"/>
           </a:p>
@@ -4982,53 +4796,14 @@
       </p:sp>
       <p:sp>
         <p:nvSpPr>
-          <p:cNvPr id="12" name="Text 10"/>
-          <p:cNvSpPr/>
-          <p:nvPr/>
-        </p:nvSpPr>
-        <p:spPr>
-          <a:xfrm>
-            <a:off x="777240" y="3419856"/>
-            <a:ext cx="4572000" cy="320040"/>
-          </a:xfrm>
-          <a:prstGeom prst="rect">
-            <a:avLst/>
-          </a:prstGeom>
-          <a:noFill/>
-          <a:ln/>
-        </p:spPr>
-        <p:txBody>
-          <a:bodyPr wrap="square" lIns="0" tIns="0" rIns="0" bIns="0" rtlCol="0" anchor="ctr"/>
-          <a:lstStyle/>
-          <a:p>
-            <a:pPr algn="ctr" indent="0" marL="0">
-              <a:buNone/>
-            </a:pPr>
-            <a:r>
-              <a:rPr lang="en-US" sz="1800" b="1" dirty="0">
-                <a:solidFill>
-                  <a:srgbClr val="F0A868"/>
-                </a:solidFill>
-                <a:latin typeface="Montserrat" pitchFamily="34" charset="0"/>
-                <a:ea typeface="Montserrat" pitchFamily="34" charset="-122"/>
-                <a:cs typeface="Montserrat" pitchFamily="34" charset="-120"/>
-              </a:rPr>
-              <a:t>↓</a:t>
-            </a:r>
-            <a:endParaRPr lang="en-US" sz="1800" dirty="0"/>
-          </a:p>
-        </p:txBody>
-      </p:sp>
-      <p:sp>
-        <p:nvSpPr>
-          <p:cNvPr id="13" name="Shape 11"/>
+          <p:cNvPr id="14" name="Shape 9"/>
           <p:cNvSpPr/>
           <p:nvPr/>
         </p:nvSpPr>
         <p:spPr>
           <a:xfrm>
             <a:off x="777240" y="3657600"/>
-            <a:ext cx="4572000" cy="658368"/>
+            <a:ext cx="4754880" cy="658368"/>
           </a:xfrm>
           <a:prstGeom prst="roundRect">
             <a:avLst>
@@ -5048,16 +4823,78 @@
           </a:effectLst>
         </p:spPr>
       </p:sp>
-      <p:sp>
-        <p:nvSpPr>
-          <p:cNvPr id="14" name="Text 12"/>
-          <p:cNvSpPr/>
-          <p:nvPr/>
-        </p:nvSpPr>
-        <p:spPr>
-          <a:xfrm>
-            <a:off x="905256" y="3657600"/>
-            <a:ext cx="685800" cy="658368"/>
+      <p:pic>
+        <p:nvPicPr>
+          <p:cNvPr id="15" name="Image 2" descr="/home/user/Wristworkswebsite/presentation/icon_menu_l.png">    </p:cNvPr>
+          <p:cNvPicPr>
+            <a:picLocks noChangeAspect="1"/>
+          </p:cNvPicPr>
+          <p:nvPr/>
+        </p:nvPicPr>
+        <p:blipFill>
+          <a:blip r:embed="rId4"/>
+          <a:srcRect l="0" r="0" t="0" b="0"/>
+          <a:stretch/>
+        </p:blipFill>
+        <p:spPr>
+          <a:xfrm>
+            <a:off x="923544" y="3776472"/>
+            <a:ext cx="457200" cy="420624"/>
+          </a:xfrm>
+          <a:prstGeom prst="rect">
+            <a:avLst/>
+          </a:prstGeom>
+        </p:spPr>
+      </p:pic>
+      <p:sp>
+        <p:nvSpPr>
+          <p:cNvPr id="16" name="Text 10"/>
+          <p:cNvSpPr/>
+          <p:nvPr/>
+        </p:nvSpPr>
+        <p:spPr>
+          <a:xfrm>
+            <a:off x="1527048" y="3657600"/>
+            <a:ext cx="3840480" cy="658368"/>
+          </a:xfrm>
+          <a:prstGeom prst="rect">
+            <a:avLst/>
+          </a:prstGeom>
+          <a:noFill/>
+          <a:ln/>
+        </p:spPr>
+        <p:txBody>
+          <a:bodyPr wrap="square" lIns="0" tIns="0" rIns="0" bIns="0" rtlCol="0" anchor="ctr"/>
+          <a:lstStyle/>
+          <a:p>
+            <a:pPr algn="l" indent="0" marL="0">
+              <a:buNone/>
+            </a:pPr>
+            <a:r>
+              <a:rPr lang="en-US" sz="1800" b="1" dirty="0">
+                <a:solidFill>
+                  <a:srgbClr val="FDF6EC"/>
+                </a:solidFill>
+                <a:latin typeface="Montserrat" pitchFamily="34" charset="0"/>
+                <a:ea typeface="Montserrat" pitchFamily="34" charset="-122"/>
+                <a:cs typeface="Montserrat" pitchFamily="34" charset="-120"/>
+              </a:rPr>
+              <a:t>WHAT WE READ</a:t>
+            </a:r>
+            <a:endParaRPr lang="en-US" sz="1800" dirty="0"/>
+          </a:p>
+        </p:txBody>
+      </p:sp>
+      <p:sp>
+        <p:nvSpPr>
+          <p:cNvPr id="17" name="Text 11"/>
+          <p:cNvSpPr/>
+          <p:nvPr/>
+        </p:nvSpPr>
+        <p:spPr>
+          <a:xfrm>
+            <a:off x="777240" y="4242816"/>
+            <a:ext cx="4754880" cy="320040"/>
           </a:xfrm>
           <a:prstGeom prst="rect">
             <a:avLst/>
@@ -5073,51 +4910,15 @@
               <a:buNone/>
             </a:pPr>
             <a:r>
-              <a:rPr lang="en-US" sz="2600" dirty="0">
-                <a:solidFill>
-                  <a:srgbClr val="000000"/>
-                </a:solidFill>
-              </a:rPr>
-              <a:t>📋</a:t>
-            </a:r>
-            <a:endParaRPr lang="en-US" sz="2600" dirty="0"/>
-          </a:p>
-        </p:txBody>
-      </p:sp>
-      <p:sp>
-        <p:nvSpPr>
-          <p:cNvPr id="15" name="Text 13"/>
-          <p:cNvSpPr/>
-          <p:nvPr/>
-        </p:nvSpPr>
-        <p:spPr>
-          <a:xfrm>
-            <a:off x="1645920" y="3657600"/>
-            <a:ext cx="3566160" cy="658368"/>
-          </a:xfrm>
-          <a:prstGeom prst="rect">
-            <a:avLst/>
-          </a:prstGeom>
-          <a:noFill/>
-          <a:ln/>
-        </p:spPr>
-        <p:txBody>
-          <a:bodyPr wrap="square" lIns="0" tIns="0" rIns="0" bIns="0" rtlCol="0" anchor="ctr"/>
-          <a:lstStyle/>
-          <a:p>
-            <a:pPr algn="l" indent="0" marL="0">
-              <a:buNone/>
-            </a:pPr>
-            <a:r>
               <a:rPr lang="en-US" sz="1800" b="1" dirty="0">
                 <a:solidFill>
-                  <a:srgbClr val="FDF6EC"/>
-                </a:solidFill>
-                <a:latin typeface="Montserrat" pitchFamily="34" charset="0"/>
-                <a:ea typeface="Montserrat" pitchFamily="34" charset="-122"/>
-                <a:cs typeface="Montserrat" pitchFamily="34" charset="-120"/>
-              </a:rPr>
-              <a:t>WHAT WE READ</a:t>
+                  <a:srgbClr val="E8722C"/>
+                </a:solidFill>
+                <a:latin typeface="Montserrat" pitchFamily="34" charset="0"/>
+                <a:ea typeface="Montserrat" pitchFamily="34" charset="-122"/>
+                <a:cs typeface="Montserrat" pitchFamily="34" charset="-120"/>
+              </a:rPr>
+              <a:t>↓</a:t>
             </a:r>
             <a:endParaRPr lang="en-US" sz="1800" dirty="0"/>
           </a:p>
@@ -5125,53 +4926,14 @@
       </p:sp>
       <p:sp>
         <p:nvSpPr>
-          <p:cNvPr id="16" name="Text 14"/>
-          <p:cNvSpPr/>
-          <p:nvPr/>
-        </p:nvSpPr>
-        <p:spPr>
-          <a:xfrm>
-            <a:off x="777240" y="4242816"/>
-            <a:ext cx="4572000" cy="320040"/>
-          </a:xfrm>
-          <a:prstGeom prst="rect">
-            <a:avLst/>
-          </a:prstGeom>
-          <a:noFill/>
-          <a:ln/>
-        </p:spPr>
-        <p:txBody>
-          <a:bodyPr wrap="square" lIns="0" tIns="0" rIns="0" bIns="0" rtlCol="0" anchor="ctr"/>
-          <a:lstStyle/>
-          <a:p>
-            <a:pPr algn="ctr" indent="0" marL="0">
-              <a:buNone/>
-            </a:pPr>
-            <a:r>
-              <a:rPr lang="en-US" sz="1800" b="1" dirty="0">
-                <a:solidFill>
-                  <a:srgbClr val="D9433C"/>
-                </a:solidFill>
-                <a:latin typeface="Montserrat" pitchFamily="34" charset="0"/>
-                <a:ea typeface="Montserrat" pitchFamily="34" charset="-122"/>
-                <a:cs typeface="Montserrat" pitchFamily="34" charset="-120"/>
-              </a:rPr>
-              <a:t>↓</a:t>
-            </a:r>
-            <a:endParaRPr lang="en-US" sz="1800" dirty="0"/>
-          </a:p>
-        </p:txBody>
-      </p:sp>
-      <p:sp>
-        <p:nvSpPr>
-          <p:cNvPr id="17" name="Shape 15"/>
+          <p:cNvPr id="18" name="Shape 12"/>
           <p:cNvSpPr/>
           <p:nvPr/>
         </p:nvSpPr>
         <p:spPr>
           <a:xfrm>
             <a:off x="777240" y="4480560"/>
-            <a:ext cx="4572000" cy="658368"/>
+            <a:ext cx="4754880" cy="658368"/>
           </a:xfrm>
           <a:prstGeom prst="roundRect">
             <a:avLst>
@@ -5191,16 +4953,78 @@
           </a:effectLst>
         </p:spPr>
       </p:sp>
-      <p:sp>
-        <p:nvSpPr>
-          <p:cNvPr id="18" name="Text 16"/>
-          <p:cNvSpPr/>
-          <p:nvPr/>
-        </p:nvSpPr>
-        <p:spPr>
-          <a:xfrm>
-            <a:off x="905256" y="4480560"/>
-            <a:ext cx="685800" cy="658368"/>
+      <p:pic>
+        <p:nvPicPr>
+          <p:cNvPr id="19" name="Image 3" descr="/home/user/Wristworkswebsite/presentation/icon_heart_l.png">    </p:cNvPr>
+          <p:cNvPicPr>
+            <a:picLocks noChangeAspect="1"/>
+          </p:cNvPicPr>
+          <p:nvPr/>
+        </p:nvPicPr>
+        <p:blipFill>
+          <a:blip r:embed="rId5"/>
+          <a:srcRect l="0" r="0" t="0" b="0"/>
+          <a:stretch/>
+        </p:blipFill>
+        <p:spPr>
+          <a:xfrm>
+            <a:off x="923544" y="4599432"/>
+            <a:ext cx="457200" cy="420624"/>
+          </a:xfrm>
+          <a:prstGeom prst="rect">
+            <a:avLst/>
+          </a:prstGeom>
+        </p:spPr>
+      </p:pic>
+      <p:sp>
+        <p:nvSpPr>
+          <p:cNvPr id="20" name="Text 13"/>
+          <p:cNvSpPr/>
+          <p:nvPr/>
+        </p:nvSpPr>
+        <p:spPr>
+          <a:xfrm>
+            <a:off x="1527048" y="4480560"/>
+            <a:ext cx="3840480" cy="658368"/>
+          </a:xfrm>
+          <a:prstGeom prst="rect">
+            <a:avLst/>
+          </a:prstGeom>
+          <a:noFill/>
+          <a:ln/>
+        </p:spPr>
+        <p:txBody>
+          <a:bodyPr wrap="square" lIns="0" tIns="0" rIns="0" bIns="0" rtlCol="0" anchor="ctr"/>
+          <a:lstStyle/>
+          <a:p>
+            <a:pPr algn="l" indent="0" marL="0">
+              <a:buNone/>
+            </a:pPr>
+            <a:r>
+              <a:rPr lang="en-US" sz="1800" b="1" dirty="0">
+                <a:solidFill>
+                  <a:srgbClr val="FDF6EC"/>
+                </a:solidFill>
+                <a:latin typeface="Montserrat" pitchFamily="34" charset="0"/>
+                <a:ea typeface="Montserrat" pitchFamily="34" charset="-122"/>
+                <a:cs typeface="Montserrat" pitchFamily="34" charset="-120"/>
+              </a:rPr>
+              <a:t>WHAT WE REMEMBER</a:t>
+            </a:r>
+            <a:endParaRPr lang="en-US" sz="1800" dirty="0"/>
+          </a:p>
+        </p:txBody>
+      </p:sp>
+      <p:sp>
+        <p:nvSpPr>
+          <p:cNvPr id="21" name="Text 14"/>
+          <p:cNvSpPr/>
+          <p:nvPr/>
+        </p:nvSpPr>
+        <p:spPr>
+          <a:xfrm>
+            <a:off x="777240" y="5065776"/>
+            <a:ext cx="4754880" cy="320040"/>
           </a:xfrm>
           <a:prstGeom prst="rect">
             <a:avLst/>
@@ -5216,51 +5040,15 @@
               <a:buNone/>
             </a:pPr>
             <a:r>
-              <a:rPr lang="en-US" sz="2600" dirty="0">
-                <a:solidFill>
-                  <a:srgbClr val="000000"/>
-                </a:solidFill>
-              </a:rPr>
-              <a:t>❤️</a:t>
-            </a:r>
-            <a:endParaRPr lang="en-US" sz="2600" dirty="0"/>
-          </a:p>
-        </p:txBody>
-      </p:sp>
-      <p:sp>
-        <p:nvSpPr>
-          <p:cNvPr id="19" name="Text 17"/>
-          <p:cNvSpPr/>
-          <p:nvPr/>
-        </p:nvSpPr>
-        <p:spPr>
-          <a:xfrm>
-            <a:off x="1645920" y="4480560"/>
-            <a:ext cx="3566160" cy="658368"/>
-          </a:xfrm>
-          <a:prstGeom prst="rect">
-            <a:avLst/>
-          </a:prstGeom>
-          <a:noFill/>
-          <a:ln/>
-        </p:spPr>
-        <p:txBody>
-          <a:bodyPr wrap="square" lIns="0" tIns="0" rIns="0" bIns="0" rtlCol="0" anchor="ctr"/>
-          <a:lstStyle/>
-          <a:p>
-            <a:pPr algn="l" indent="0" marL="0">
-              <a:buNone/>
-            </a:pPr>
-            <a:r>
               <a:rPr lang="en-US" sz="1800" b="1" dirty="0">
                 <a:solidFill>
-                  <a:srgbClr val="FDF6EC"/>
-                </a:solidFill>
-                <a:latin typeface="Montserrat" pitchFamily="34" charset="0"/>
-                <a:ea typeface="Montserrat" pitchFamily="34" charset="-122"/>
-                <a:cs typeface="Montserrat" pitchFamily="34" charset="-120"/>
-              </a:rPr>
-              <a:t>WHAT WE REMEMBER</a:t>
+                  <a:srgbClr val="E8722C"/>
+                </a:solidFill>
+                <a:latin typeface="Montserrat" pitchFamily="34" charset="0"/>
+                <a:ea typeface="Montserrat" pitchFamily="34" charset="-122"/>
+                <a:cs typeface="Montserrat" pitchFamily="34" charset="-120"/>
+              </a:rPr>
+              <a:t>↓</a:t>
             </a:r>
             <a:endParaRPr lang="en-US" sz="1800" dirty="0"/>
           </a:p>
@@ -5268,53 +5056,14 @@
       </p:sp>
       <p:sp>
         <p:nvSpPr>
-          <p:cNvPr id="20" name="Text 18"/>
-          <p:cNvSpPr/>
-          <p:nvPr/>
-        </p:nvSpPr>
-        <p:spPr>
-          <a:xfrm>
-            <a:off x="777240" y="5065776"/>
-            <a:ext cx="4572000" cy="320040"/>
-          </a:xfrm>
-          <a:prstGeom prst="rect">
-            <a:avLst/>
-          </a:prstGeom>
-          <a:noFill/>
-          <a:ln/>
-        </p:spPr>
-        <p:txBody>
-          <a:bodyPr wrap="square" lIns="0" tIns="0" rIns="0" bIns="0" rtlCol="0" anchor="ctr"/>
-          <a:lstStyle/>
-          <a:p>
-            <a:pPr algn="ctr" indent="0" marL="0">
-              <a:buNone/>
-            </a:pPr>
-            <a:r>
-              <a:rPr lang="en-US" sz="1800" b="1" dirty="0">
-                <a:solidFill>
-                  <a:srgbClr val="E88A6A"/>
-                </a:solidFill>
-                <a:latin typeface="Montserrat" pitchFamily="34" charset="0"/>
-                <a:ea typeface="Montserrat" pitchFamily="34" charset="-122"/>
-                <a:cs typeface="Montserrat" pitchFamily="34" charset="-120"/>
-              </a:rPr>
-              <a:t>↓</a:t>
-            </a:r>
-            <a:endParaRPr lang="en-US" sz="1800" dirty="0"/>
-          </a:p>
-        </p:txBody>
-      </p:sp>
-      <p:sp>
-        <p:nvSpPr>
-          <p:cNvPr id="21" name="Shape 19"/>
+          <p:cNvPr id="22" name="Shape 15"/>
           <p:cNvSpPr/>
           <p:nvPr/>
         </p:nvSpPr>
         <p:spPr>
           <a:xfrm>
             <a:off x="777240" y="5303520"/>
-            <a:ext cx="4572000" cy="658368"/>
+            <a:ext cx="4754880" cy="658368"/>
           </a:xfrm>
           <a:prstGeom prst="roundRect">
             <a:avLst>
@@ -5334,52 +5083,39 @@
           </a:effectLst>
         </p:spPr>
       </p:sp>
-      <p:sp>
-        <p:nvSpPr>
-          <p:cNvPr id="22" name="Text 20"/>
-          <p:cNvSpPr/>
-          <p:nvPr/>
-        </p:nvSpPr>
-        <p:spPr>
-          <a:xfrm>
-            <a:off x="905256" y="5303520"/>
-            <a:ext cx="685800" cy="658368"/>
-          </a:xfrm>
-          <a:prstGeom prst="rect">
-            <a:avLst/>
-          </a:prstGeom>
-          <a:noFill/>
-          <a:ln/>
-        </p:spPr>
-        <p:txBody>
-          <a:bodyPr wrap="square" lIns="0" tIns="0" rIns="0" bIns="0" rtlCol="0" anchor="ctr"/>
-          <a:lstStyle/>
-          <a:p>
-            <a:pPr algn="ctr" indent="0" marL="0">
-              <a:buNone/>
-            </a:pPr>
-            <a:r>
-              <a:rPr lang="en-US" sz="2600" dirty="0">
-                <a:solidFill>
-                  <a:srgbClr val="000000"/>
-                </a:solidFill>
-              </a:rPr>
-              <a:t>🍴</a:t>
-            </a:r>
-            <a:endParaRPr lang="en-US" sz="2600" dirty="0"/>
-          </a:p>
-        </p:txBody>
-      </p:sp>
-      <p:sp>
-        <p:nvSpPr>
-          <p:cNvPr id="23" name="Text 21"/>
-          <p:cNvSpPr/>
-          <p:nvPr/>
-        </p:nvSpPr>
-        <p:spPr>
-          <a:xfrm>
-            <a:off x="1645920" y="5303520"/>
-            <a:ext cx="3566160" cy="658368"/>
+      <p:pic>
+        <p:nvPicPr>
+          <p:cNvPr id="23" name="Image 4" descr="/home/user/Wristworkswebsite/presentation/icon_fork.png">    </p:cNvPr>
+          <p:cNvPicPr>
+            <a:picLocks noChangeAspect="1"/>
+          </p:cNvPicPr>
+          <p:nvPr/>
+        </p:nvPicPr>
+        <p:blipFill>
+          <a:blip r:embed="rId6"/>
+          <a:srcRect l="0" r="0" t="0" b="0"/>
+          <a:stretch/>
+        </p:blipFill>
+        <p:spPr>
+          <a:xfrm>
+            <a:off x="923544" y="5422392"/>
+            <a:ext cx="457200" cy="420624"/>
+          </a:xfrm>
+          <a:prstGeom prst="rect">
+            <a:avLst/>
+          </a:prstGeom>
+        </p:spPr>
+      </p:pic>
+      <p:sp>
+        <p:nvSpPr>
+          <p:cNvPr id="24" name="Text 16"/>
+          <p:cNvSpPr/>
+          <p:nvPr/>
+        </p:nvSpPr>
+        <p:spPr>
+          <a:xfrm>
+            <a:off x="1527048" y="5303520"/>
+            <a:ext cx="3840480" cy="658368"/>
           </a:xfrm>
           <a:prstGeom prst="rect">
             <a:avLst/>
@@ -5411,7 +5147,7 @@
       </p:sp>
       <p:sp>
         <p:nvSpPr>
-          <p:cNvPr id="24" name="Text 22"/>
+          <p:cNvPr id="25" name="Text 17"/>
           <p:cNvSpPr/>
           <p:nvPr/>
         </p:nvSpPr>
@@ -5450,7 +5186,7 @@
       </p:sp>
       <p:sp>
         <p:nvSpPr>
-          <p:cNvPr id="25" name="Text 23"/>
+          <p:cNvPr id="26" name="Text 18"/>
           <p:cNvSpPr/>
           <p:nvPr/>
         </p:nvSpPr>
@@ -5489,7 +5225,7 @@
       </p:sp>
       <p:sp>
         <p:nvSpPr>
-          <p:cNvPr id="26" name="Shape 24"/>
+          <p:cNvPr id="27" name="Shape 19"/>
           <p:cNvSpPr/>
           <p:nvPr/>
         </p:nvSpPr>
@@ -5518,7 +5254,7 @@
       </p:sp>
       <p:sp>
         <p:nvSpPr>
-          <p:cNvPr id="27" name="Text 25"/>
+          <p:cNvPr id="28" name="Text 20"/>
           <p:cNvSpPr/>
           <p:nvPr/>
         </p:nvSpPr>
@@ -5557,7 +5293,7 @@
       </p:sp>
       <p:sp>
         <p:nvSpPr>
-          <p:cNvPr id="28" name="Text 26"/>
+          <p:cNvPr id="29" name="Text 21"/>
           <p:cNvSpPr/>
           <p:nvPr/>
         </p:nvSpPr>
@@ -5596,7 +5332,7 @@
       </p:sp>
       <p:sp>
         <p:nvSpPr>
-          <p:cNvPr id="29" name="Text 27"/>
+          <p:cNvPr id="30" name="Text 22"/>
           <p:cNvSpPr/>
           <p:nvPr/>
         </p:nvSpPr>

</xml_diff>